<commit_message>
Update explanatory note and presentation files
Co-authored-by: arena-agent <297053741+arena-agent@users.noreply.github.com>
</commit_message>
<xml_diff>
--- a/reports/lab7/LR7_Presentation_Variant15.pptx
+++ b/reports/lab7/LR7_Presentation_Variant15.pptx
@@ -14,9 +14,6 @@
     <p:sldId id="262" r:id="rId13"/>
     <p:sldId id="263" r:id="rId14"/>
     <p:sldId id="264" r:id="rId15"/>
-    <p:sldId id="265" r:id="rId16"/>
-    <p:sldId id="266" r:id="rId17"/>
-    <p:sldId id="267" r:id="rId18"/>
   </p:sldIdLst>
   <p:sldSz cx="12191695" cy="6858000" type="screen4x3"/>
   <p:notesSz cx="6858000" cy="9144000"/>
@@ -3092,6 +3089,14 @@
 <file path=ppt/slides/slide1.xml><?xml version="1.0" encoding="utf-8"?>
 <p:sld xmlns:a="http://schemas.openxmlformats.org/drawingml/2006/main" xmlns:p="http://schemas.openxmlformats.org/presentationml/2006/main" xmlns:r="http://schemas.openxmlformats.org/officeDocument/2006/relationships">
   <p:cSld>
+    <p:bg>
+      <p:bgPr>
+        <a:solidFill>
+          <a:srgbClr val="F8FAFC"/>
+        </a:solidFill>
+        <a:effectLst/>
+      </p:bgPr>
+    </p:bg>
     <p:spTree>
       <p:nvGrpSpPr>
         <p:cNvPr id="1" name=""/>
@@ -3099,156 +3104,126 @@
         <p:nvPr/>
       </p:nvGrpSpPr>
       <p:grpSpPr/>
-      <p:pic>
-        <p:nvPicPr>
-          <p:cNvPr id="2" name="Picture 1" descr="slide_01_title.png"/>
-          <p:cNvPicPr>
-            <a:picLocks noChangeAspect="1"/>
-          </p:cNvPicPr>
+      <p:sp>
+        <p:nvSpPr>
+          <p:cNvPr id="2" name="Rectangle 1"/>
+          <p:cNvSpPr/>
           <p:nvPr/>
-        </p:nvPicPr>
-        <p:blipFill>
-          <a:blip r:embed="rId2"/>
-          <a:stretch>
-            <a:fillRect/>
-          </a:stretch>
-        </p:blipFill>
+        </p:nvSpPr>
         <p:spPr>
           <a:xfrm>
-            <a:off x="0" y="0"/>
-            <a:ext cx="12191695" cy="6858000"/>
+            <a:off x="502920" y="502920"/>
+            <a:ext cx="11155680" cy="777240"/>
           </a:xfrm>
           <a:prstGeom prst="rect">
             <a:avLst/>
           </a:prstGeom>
+          <a:solidFill>
+            <a:srgbClr val="0F172A"/>
+          </a:solidFill>
+          <a:ln>
+            <a:noFill/>
+          </a:ln>
         </p:spPr>
-      </p:pic>
-    </p:spTree>
-  </p:cSld>
-  <p:clrMapOvr>
-    <a:masterClrMapping/>
-  </p:clrMapOvr>
-</p:sld>
-</file>
-
-<file path=ppt/slides/slide10.xml><?xml version="1.0" encoding="utf-8"?>
-<p:sld xmlns:a="http://schemas.openxmlformats.org/drawingml/2006/main" xmlns:p="http://schemas.openxmlformats.org/presentationml/2006/main" xmlns:r="http://schemas.openxmlformats.org/officeDocument/2006/relationships">
-  <p:cSld>
-    <p:spTree>
-      <p:nvGrpSpPr>
-        <p:cNvPr id="1" name=""/>
-        <p:cNvGrpSpPr/>
-        <p:nvPr/>
-      </p:nvGrpSpPr>
-      <p:grpSpPr/>
-      <p:pic>
-        <p:nvPicPr>
-          <p:cNvPr id="2" name="Picture 1" descr="slide_10_interactive_ux.png"/>
-          <p:cNvPicPr>
-            <a:picLocks noChangeAspect="1"/>
-          </p:cNvPicPr>
+        <p:style>
+          <a:lnRef idx="1">
+            <a:schemeClr val="accent1"/>
+          </a:lnRef>
+          <a:fillRef idx="3">
+            <a:schemeClr val="accent1"/>
+          </a:fillRef>
+          <a:effectRef idx="2">
+            <a:schemeClr val="accent1"/>
+          </a:effectRef>
+          <a:fontRef idx="minor">
+            <a:schemeClr val="lt1"/>
+          </a:fontRef>
+        </p:style>
+        <p:txBody>
+          <a:bodyPr rtlCol="0" anchor="ctr"/>
+          <a:lstStyle/>
+          <a:p>
+            <a:pPr>
+              <a:defRPr sz="2700" b="1">
+                <a:solidFill>
+                  <a:srgbClr val="FFFFFF"/>
+                </a:solidFill>
+              </a:defRPr>
+            </a:pPr>
+            <a:r>
+              <a:t>Портал Центра АНОК</a:t>
+            </a:r>
+          </a:p>
+        </p:txBody>
+      </p:sp>
+      <p:sp>
+        <p:nvSpPr>
+          <p:cNvPr id="3" name="TextBox 2"/>
+          <p:cNvSpPr txBox="1"/>
           <p:nvPr/>
-        </p:nvPicPr>
-        <p:blipFill>
-          <a:blip r:embed="rId2"/>
-          <a:stretch>
-            <a:fillRect/>
-          </a:stretch>
-        </p:blipFill>
+        </p:nvSpPr>
         <p:spPr>
           <a:xfrm>
-            <a:off x="0" y="0"/>
-            <a:ext cx="12191695" cy="6858000"/>
+            <a:off x="731520" y="1600200"/>
+            <a:ext cx="10698480" cy="4389120"/>
           </a:xfrm>
           <a:prstGeom prst="rect">
             <a:avLst/>
           </a:prstGeom>
+          <a:noFill/>
         </p:spPr>
-      </p:pic>
-    </p:spTree>
-  </p:cSld>
-  <p:clrMapOvr>
-    <a:masterClrMapping/>
-  </p:clrMapOvr>
-</p:sld>
-</file>
-
-<file path=ppt/slides/slide11.xml><?xml version="1.0" encoding="utf-8"?>
-<p:sld xmlns:a="http://schemas.openxmlformats.org/drawingml/2006/main" xmlns:p="http://schemas.openxmlformats.org/presentationml/2006/main" xmlns:r="http://schemas.openxmlformats.org/officeDocument/2006/relationships">
-  <p:cSld>
-    <p:spTree>
-      <p:nvGrpSpPr>
-        <p:cNvPr id="1" name=""/>
-        <p:cNvGrpSpPr/>
-        <p:nvPr/>
-      </p:nvGrpSpPr>
-      <p:grpSpPr/>
-      <p:pic>
-        <p:nvPicPr>
-          <p:cNvPr id="2" name="Picture 1" descr="slide_11_testing_security.png"/>
-          <p:cNvPicPr>
-            <a:picLocks noChangeAspect="1"/>
-          </p:cNvPicPr>
-          <p:nvPr/>
-        </p:nvPicPr>
-        <p:blipFill>
-          <a:blip r:embed="rId2"/>
-          <a:stretch>
-            <a:fillRect/>
-          </a:stretch>
-        </p:blipFill>
-        <p:spPr>
-          <a:xfrm>
-            <a:off x="0" y="0"/>
-            <a:ext cx="12191695" cy="6858000"/>
-          </a:xfrm>
-          <a:prstGeom prst="rect">
-            <a:avLst/>
-          </a:prstGeom>
-        </p:spPr>
-      </p:pic>
-    </p:spTree>
-  </p:cSld>
-  <p:clrMapOvr>
-    <a:masterClrMapping/>
-  </p:clrMapOvr>
-</p:sld>
-</file>
-
-<file path=ppt/slides/slide12.xml><?xml version="1.0" encoding="utf-8"?>
-<p:sld xmlns:a="http://schemas.openxmlformats.org/drawingml/2006/main" xmlns:p="http://schemas.openxmlformats.org/presentationml/2006/main" xmlns:r="http://schemas.openxmlformats.org/officeDocument/2006/relationships">
-  <p:cSld>
-    <p:spTree>
-      <p:nvGrpSpPr>
-        <p:cNvPr id="1" name=""/>
-        <p:cNvGrpSpPr/>
-        <p:nvPr/>
-      </p:nvGrpSpPr>
-      <p:grpSpPr/>
-      <p:pic>
-        <p:nvPicPr>
-          <p:cNvPr id="2" name="Picture 1" descr="slide_12_conclusion_impact.png"/>
-          <p:cNvPicPr>
-            <a:picLocks noChangeAspect="1"/>
-          </p:cNvPicPr>
-          <p:nvPr/>
-        </p:nvPicPr>
-        <p:blipFill>
-          <a:blip r:embed="rId2"/>
-          <a:stretch>
-            <a:fillRect/>
-          </a:stretch>
-        </p:blipFill>
-        <p:spPr>
-          <a:xfrm>
-            <a:off x="0" y="0"/>
-            <a:ext cx="12191695" cy="6858000"/>
-          </a:xfrm>
-          <a:prstGeom prst="rect">
-            <a:avLst/>
-          </a:prstGeom>
-        </p:spPr>
-      </p:pic>
+        <p:txBody>
+          <a:bodyPr wrap="square">
+            <a:spAutoFit/>
+          </a:bodyPr>
+          <a:lstStyle/>
+          <a:p>
+            <a:pPr>
+              <a:spcAft>
+                <a:spcPts val="1200"/>
+              </a:spcAft>
+              <a:defRPr sz="2200">
+                <a:solidFill>
+                  <a:srgbClr val="1E293B"/>
+                </a:solidFill>
+              </a:defRPr>
+            </a:pPr>
+            <a:r>
+              <a:t>Учебный прототип</a:t>
+            </a:r>
+          </a:p>
+          <a:p>
+            <a:pPr>
+              <a:spcAft>
+                <a:spcPts val="1200"/>
+              </a:spcAft>
+              <a:defRPr sz="2200">
+                <a:solidFill>
+                  <a:srgbClr val="1E293B"/>
+                </a:solidFill>
+              </a:defRPr>
+            </a:pPr>
+            <a:r>
+              <a:t>Вариант 15 — Университет</a:t>
+            </a:r>
+          </a:p>
+          <a:p>
+            <a:pPr>
+              <a:spcAft>
+                <a:spcPts val="1200"/>
+              </a:spcAft>
+              <a:defRPr sz="2200">
+                <a:solidFill>
+                  <a:srgbClr val="1E293B"/>
+                </a:solidFill>
+              </a:defRPr>
+            </a:pPr>
+            <a:r>
+              <a:t>Flask + SQLite</a:t>
+            </a:r>
+          </a:p>
+        </p:txBody>
+      </p:sp>
     </p:spTree>
   </p:cSld>
   <p:clrMapOvr>
@@ -3260,6 +3235,14 @@
 <file path=ppt/slides/slide2.xml><?xml version="1.0" encoding="utf-8"?>
 <p:sld xmlns:a="http://schemas.openxmlformats.org/drawingml/2006/main" xmlns:p="http://schemas.openxmlformats.org/presentationml/2006/main" xmlns:r="http://schemas.openxmlformats.org/officeDocument/2006/relationships">
   <p:cSld>
+    <p:bg>
+      <p:bgPr>
+        <a:solidFill>
+          <a:srgbClr val="F8FAFC"/>
+        </a:solidFill>
+        <a:effectLst/>
+      </p:bgPr>
+    </p:bg>
     <p:spTree>
       <p:nvGrpSpPr>
         <p:cNvPr id="1" name=""/>
@@ -3267,30 +3250,123 @@
         <p:nvPr/>
       </p:nvGrpSpPr>
       <p:grpSpPr/>
-      <p:pic>
-        <p:nvPicPr>
-          <p:cNvPr id="2" name="Picture 1" descr="slide_02_context_goals.png"/>
-          <p:cNvPicPr>
-            <a:picLocks noChangeAspect="1"/>
-          </p:cNvPicPr>
+      <p:sp>
+        <p:nvSpPr>
+          <p:cNvPr id="2" name="Rectangle 1"/>
+          <p:cNvSpPr/>
           <p:nvPr/>
-        </p:nvPicPr>
-        <p:blipFill>
-          <a:blip r:embed="rId2"/>
-          <a:stretch>
-            <a:fillRect/>
-          </a:stretch>
-        </p:blipFill>
+        </p:nvSpPr>
         <p:spPr>
           <a:xfrm>
-            <a:off x="0" y="0"/>
-            <a:ext cx="12191695" cy="6858000"/>
+            <a:off x="502920" y="502920"/>
+            <a:ext cx="11155680" cy="777240"/>
           </a:xfrm>
           <a:prstGeom prst="rect">
             <a:avLst/>
           </a:prstGeom>
+          <a:solidFill>
+            <a:srgbClr val="0F172A"/>
+          </a:solidFill>
+          <a:ln>
+            <a:noFill/>
+          </a:ln>
         </p:spPr>
-      </p:pic>
+        <p:style>
+          <a:lnRef idx="1">
+            <a:schemeClr val="accent1"/>
+          </a:lnRef>
+          <a:fillRef idx="3">
+            <a:schemeClr val="accent1"/>
+          </a:fillRef>
+          <a:effectRef idx="2">
+            <a:schemeClr val="accent1"/>
+          </a:effectRef>
+          <a:fontRef idx="minor">
+            <a:schemeClr val="lt1"/>
+          </a:fontRef>
+        </p:style>
+        <p:txBody>
+          <a:bodyPr rtlCol="0" anchor="ctr"/>
+          <a:lstStyle/>
+          <a:p>
+            <a:pPr>
+              <a:defRPr sz="2700" b="1">
+                <a:solidFill>
+                  <a:srgbClr val="FFFFFF"/>
+                </a:solidFill>
+              </a:defRPr>
+            </a:pPr>
+            <a:r>
+              <a:t>Назначение</a:t>
+            </a:r>
+          </a:p>
+        </p:txBody>
+      </p:sp>
+      <p:sp>
+        <p:nvSpPr>
+          <p:cNvPr id="3" name="TextBox 2"/>
+          <p:cNvSpPr txBox="1"/>
+          <p:nvPr/>
+        </p:nvSpPr>
+        <p:spPr>
+          <a:xfrm>
+            <a:off x="731520" y="1600200"/>
+            <a:ext cx="10698480" cy="4389120"/>
+          </a:xfrm>
+          <a:prstGeom prst="rect">
+            <a:avLst/>
+          </a:prstGeom>
+          <a:noFill/>
+        </p:spPr>
+        <p:txBody>
+          <a:bodyPr wrap="square">
+            <a:spAutoFit/>
+          </a:bodyPr>
+          <a:lstStyle/>
+          <a:p>
+            <a:pPr>
+              <a:spcAft>
+                <a:spcPts val="1200"/>
+              </a:spcAft>
+              <a:defRPr sz="2200">
+                <a:solidFill>
+                  <a:srgbClr val="1E293B"/>
+                </a:solidFill>
+              </a:defRPr>
+            </a:pPr>
+            <a:r>
+              <a:t>Портал предназначен для просмотра учебных планов, дисциплин, стандартов ФГОС, образовательных программ и служебных записок.</a:t>
+            </a:r>
+          </a:p>
+          <a:p>
+            <a:pPr>
+              <a:spcAft>
+                <a:spcPts val="1200"/>
+              </a:spcAft>
+              <a:defRPr sz="2200">
+                <a:solidFill>
+                  <a:srgbClr val="1E293B"/>
+                </a:solidFill>
+              </a:defRPr>
+            </a:pPr>
+          </a:p>
+          <a:p>
+            <a:pPr>
+              <a:spcAft>
+                <a:spcPts val="1200"/>
+              </a:spcAft>
+              <a:defRPr sz="2200">
+                <a:solidFill>
+                  <a:srgbClr val="1E293B"/>
+                </a:solidFill>
+              </a:defRPr>
+            </a:pPr>
+            <a:r>
+              <a:t>Результат ограничен учебным прототипом.</a:t>
+            </a:r>
+          </a:p>
+        </p:txBody>
+      </p:sp>
     </p:spTree>
   </p:cSld>
   <p:clrMapOvr>
@@ -3302,6 +3378,14 @@
 <file path=ppt/slides/slide3.xml><?xml version="1.0" encoding="utf-8"?>
 <p:sld xmlns:a="http://schemas.openxmlformats.org/drawingml/2006/main" xmlns:p="http://schemas.openxmlformats.org/presentationml/2006/main" xmlns:r="http://schemas.openxmlformats.org/officeDocument/2006/relationships">
   <p:cSld>
+    <p:bg>
+      <p:bgPr>
+        <a:solidFill>
+          <a:srgbClr val="F8FAFC"/>
+        </a:solidFill>
+        <a:effectLst/>
+      </p:bgPr>
+    </p:bg>
     <p:spTree>
       <p:nvGrpSpPr>
         <p:cNvPr id="1" name=""/>
@@ -3309,30 +3393,171 @@
         <p:nvPr/>
       </p:nvGrpSpPr>
       <p:grpSpPr/>
-      <p:pic>
-        <p:nvPicPr>
-          <p:cNvPr id="2" name="Picture 1" descr="slide_03_architecture_stack.png"/>
-          <p:cNvPicPr>
-            <a:picLocks noChangeAspect="1"/>
-          </p:cNvPicPr>
+      <p:sp>
+        <p:nvSpPr>
+          <p:cNvPr id="2" name="Rectangle 1"/>
+          <p:cNvSpPr/>
           <p:nvPr/>
-        </p:nvPicPr>
-        <p:blipFill>
-          <a:blip r:embed="rId2"/>
-          <a:stretch>
-            <a:fillRect/>
-          </a:stretch>
-        </p:blipFill>
+        </p:nvSpPr>
         <p:spPr>
           <a:xfrm>
-            <a:off x="0" y="0"/>
-            <a:ext cx="12191695" cy="6858000"/>
+            <a:off x="502920" y="502920"/>
+            <a:ext cx="11155680" cy="777240"/>
           </a:xfrm>
           <a:prstGeom prst="rect">
             <a:avLst/>
           </a:prstGeom>
+          <a:solidFill>
+            <a:srgbClr val="0F172A"/>
+          </a:solidFill>
+          <a:ln>
+            <a:noFill/>
+          </a:ln>
         </p:spPr>
-      </p:pic>
+        <p:style>
+          <a:lnRef idx="1">
+            <a:schemeClr val="accent1"/>
+          </a:lnRef>
+          <a:fillRef idx="3">
+            <a:schemeClr val="accent1"/>
+          </a:fillRef>
+          <a:effectRef idx="2">
+            <a:schemeClr val="accent1"/>
+          </a:effectRef>
+          <a:fontRef idx="minor">
+            <a:schemeClr val="lt1"/>
+          </a:fontRef>
+        </p:style>
+        <p:txBody>
+          <a:bodyPr rtlCol="0" anchor="ctr"/>
+          <a:lstStyle/>
+          <a:p>
+            <a:pPr>
+              <a:defRPr sz="2700" b="1">
+                <a:solidFill>
+                  <a:srgbClr val="FFFFFF"/>
+                </a:solidFill>
+              </a:defRPr>
+            </a:pPr>
+            <a:r>
+              <a:t>Используемый стек</a:t>
+            </a:r>
+          </a:p>
+        </p:txBody>
+      </p:sp>
+      <p:sp>
+        <p:nvSpPr>
+          <p:cNvPr id="3" name="TextBox 2"/>
+          <p:cNvSpPr txBox="1"/>
+          <p:nvPr/>
+        </p:nvSpPr>
+        <p:spPr>
+          <a:xfrm>
+            <a:off x="731520" y="1600200"/>
+            <a:ext cx="10698480" cy="4389120"/>
+          </a:xfrm>
+          <a:prstGeom prst="rect">
+            <a:avLst/>
+          </a:prstGeom>
+          <a:noFill/>
+        </p:spPr>
+        <p:txBody>
+          <a:bodyPr wrap="square">
+            <a:spAutoFit/>
+          </a:bodyPr>
+          <a:lstStyle/>
+          <a:p>
+            <a:pPr>
+              <a:spcAft>
+                <a:spcPts val="1200"/>
+              </a:spcAft>
+              <a:defRPr sz="2200">
+                <a:solidFill>
+                  <a:srgbClr val="1E293B"/>
+                </a:solidFill>
+              </a:defRPr>
+            </a:pPr>
+            <a:r>
+              <a:t>Python 3</a:t>
+            </a:r>
+          </a:p>
+          <a:p>
+            <a:pPr>
+              <a:spcAft>
+                <a:spcPts val="1200"/>
+              </a:spcAft>
+              <a:defRPr sz="2200">
+                <a:solidFill>
+                  <a:srgbClr val="1E293B"/>
+                </a:solidFill>
+              </a:defRPr>
+            </a:pPr>
+            <a:r>
+              <a:t>Flask</a:t>
+            </a:r>
+          </a:p>
+          <a:p>
+            <a:pPr>
+              <a:spcAft>
+                <a:spcPts val="1200"/>
+              </a:spcAft>
+              <a:defRPr sz="2200">
+                <a:solidFill>
+                  <a:srgbClr val="1E293B"/>
+                </a:solidFill>
+              </a:defRPr>
+            </a:pPr>
+            <a:r>
+              <a:t>Jinja2</a:t>
+            </a:r>
+          </a:p>
+          <a:p>
+            <a:pPr>
+              <a:spcAft>
+                <a:spcPts val="1200"/>
+              </a:spcAft>
+              <a:defRPr sz="2200">
+                <a:solidFill>
+                  <a:srgbClr val="1E293B"/>
+                </a:solidFill>
+              </a:defRPr>
+            </a:pPr>
+            <a:r>
+              <a:t>SQLite</a:t>
+            </a:r>
+          </a:p>
+          <a:p>
+            <a:pPr>
+              <a:spcAft>
+                <a:spcPts val="1200"/>
+              </a:spcAft>
+              <a:defRPr sz="2200">
+                <a:solidFill>
+                  <a:srgbClr val="1E293B"/>
+                </a:solidFill>
+              </a:defRPr>
+            </a:pPr>
+            <a:r>
+              <a:t>HTML/CSS</a:t>
+            </a:r>
+          </a:p>
+          <a:p>
+            <a:pPr>
+              <a:spcAft>
+                <a:spcPts val="1200"/>
+              </a:spcAft>
+              <a:defRPr sz="2200">
+                <a:solidFill>
+                  <a:srgbClr val="1E293B"/>
+                </a:solidFill>
+              </a:defRPr>
+            </a:pPr>
+            <a:r>
+              <a:t>Tailwind CSS и Font Awesome из CDN</a:t>
+            </a:r>
+          </a:p>
+        </p:txBody>
+      </p:sp>
     </p:spTree>
   </p:cSld>
   <p:clrMapOvr>
@@ -3344,6 +3569,14 @@
 <file path=ppt/slides/slide4.xml><?xml version="1.0" encoding="utf-8"?>
 <p:sld xmlns:a="http://schemas.openxmlformats.org/drawingml/2006/main" xmlns:p="http://schemas.openxmlformats.org/presentationml/2006/main" xmlns:r="http://schemas.openxmlformats.org/officeDocument/2006/relationships">
   <p:cSld>
+    <p:bg>
+      <p:bgPr>
+        <a:solidFill>
+          <a:srgbClr val="F8FAFC"/>
+        </a:solidFill>
+        <a:effectLst/>
+      </p:bgPr>
+    </p:bg>
     <p:spTree>
       <p:nvGrpSpPr>
         <p:cNvPr id="1" name=""/>
@@ -3351,30 +3584,201 @@
         <p:nvPr/>
       </p:nvGrpSpPr>
       <p:grpSpPr/>
-      <p:pic>
-        <p:nvPicPr>
-          <p:cNvPr id="2" name="Picture 1" descr="slide_04_data_model.png"/>
-          <p:cNvPicPr>
-            <a:picLocks noChangeAspect="1"/>
-          </p:cNvPicPr>
+      <p:sp>
+        <p:nvSpPr>
+          <p:cNvPr id="2" name="Rectangle 1"/>
+          <p:cNvSpPr/>
           <p:nvPr/>
-        </p:nvPicPr>
-        <p:blipFill>
-          <a:blip r:embed="rId2"/>
-          <a:stretch>
-            <a:fillRect/>
-          </a:stretch>
-        </p:blipFill>
+        </p:nvSpPr>
         <p:spPr>
           <a:xfrm>
-            <a:off x="0" y="0"/>
-            <a:ext cx="12191695" cy="6858000"/>
+            <a:off x="502920" y="502920"/>
+            <a:ext cx="11155680" cy="777240"/>
           </a:xfrm>
           <a:prstGeom prst="rect">
             <a:avLst/>
           </a:prstGeom>
+          <a:solidFill>
+            <a:srgbClr val="0F172A"/>
+          </a:solidFill>
+          <a:ln>
+            <a:noFill/>
+          </a:ln>
         </p:spPr>
-      </p:pic>
+        <p:style>
+          <a:lnRef idx="1">
+            <a:schemeClr val="accent1"/>
+          </a:lnRef>
+          <a:fillRef idx="3">
+            <a:schemeClr val="accent1"/>
+          </a:fillRef>
+          <a:effectRef idx="2">
+            <a:schemeClr val="accent1"/>
+          </a:effectRef>
+          <a:fontRef idx="minor">
+            <a:schemeClr val="lt1"/>
+          </a:fontRef>
+        </p:style>
+        <p:txBody>
+          <a:bodyPr rtlCol="0" anchor="ctr"/>
+          <a:lstStyle/>
+          <a:p>
+            <a:pPr>
+              <a:defRPr sz="2700" b="1">
+                <a:solidFill>
+                  <a:srgbClr val="FFFFFF"/>
+                </a:solidFill>
+              </a:defRPr>
+            </a:pPr>
+            <a:r>
+              <a:t>Данные SQLite</a:t>
+            </a:r>
+          </a:p>
+        </p:txBody>
+      </p:sp>
+      <p:sp>
+        <p:nvSpPr>
+          <p:cNvPr id="3" name="TextBox 2"/>
+          <p:cNvSpPr txBox="1"/>
+          <p:nvPr/>
+        </p:nvSpPr>
+        <p:spPr>
+          <a:xfrm>
+            <a:off x="731520" y="1600200"/>
+            <a:ext cx="10698480" cy="4389120"/>
+          </a:xfrm>
+          <a:prstGeom prst="rect">
+            <a:avLst/>
+          </a:prstGeom>
+          <a:noFill/>
+        </p:spPr>
+        <p:txBody>
+          <a:bodyPr wrap="square">
+            <a:spAutoFit/>
+          </a:bodyPr>
+          <a:lstStyle/>
+          <a:p>
+            <a:pPr>
+              <a:spcAft>
+                <a:spcPts val="1200"/>
+              </a:spcAft>
+              <a:defRPr sz="2200">
+                <a:solidFill>
+                  <a:srgbClr val="1E293B"/>
+                </a:solidFill>
+              </a:defRPr>
+            </a:pPr>
+            <a:r>
+              <a:t>Демонстрационный набор:</a:t>
+            </a:r>
+          </a:p>
+          <a:p>
+            <a:pPr>
+              <a:spcAft>
+                <a:spcPts val="1200"/>
+              </a:spcAft>
+              <a:defRPr sz="2200">
+                <a:solidFill>
+                  <a:srgbClr val="1E293B"/>
+                </a:solidFill>
+              </a:defRPr>
+            </a:pPr>
+            <a:r>
+              <a:t>• 1 образовательная программа</a:t>
+            </a:r>
+          </a:p>
+          <a:p>
+            <a:pPr>
+              <a:spcAft>
+                <a:spcPts val="1200"/>
+              </a:spcAft>
+              <a:defRPr sz="2200">
+                <a:solidFill>
+                  <a:srgbClr val="1E293B"/>
+                </a:solidFill>
+              </a:defRPr>
+            </a:pPr>
+            <a:r>
+              <a:t>• 1 учебный план</a:t>
+            </a:r>
+          </a:p>
+          <a:p>
+            <a:pPr>
+              <a:spcAft>
+                <a:spcPts val="1200"/>
+              </a:spcAft>
+              <a:defRPr sz="2200">
+                <a:solidFill>
+                  <a:srgbClr val="1E293B"/>
+                </a:solidFill>
+              </a:defRPr>
+            </a:pPr>
+            <a:r>
+              <a:t>• 51 дисциплина</a:t>
+            </a:r>
+          </a:p>
+          <a:p>
+            <a:pPr>
+              <a:spcAft>
+                <a:spcPts val="1200"/>
+              </a:spcAft>
+              <a:defRPr sz="2200">
+                <a:solidFill>
+                  <a:srgbClr val="1E293B"/>
+                </a:solidFill>
+              </a:defRPr>
+            </a:pPr>
+            <a:r>
+              <a:t>• 3 стандарта ФГОС</a:t>
+            </a:r>
+          </a:p>
+          <a:p>
+            <a:pPr>
+              <a:spcAft>
+                <a:spcPts val="1200"/>
+              </a:spcAft>
+              <a:defRPr sz="2200">
+                <a:solidFill>
+                  <a:srgbClr val="1E293B"/>
+                </a:solidFill>
+              </a:defRPr>
+            </a:pPr>
+            <a:r>
+              <a:t>• 4 служебные записки</a:t>
+            </a:r>
+          </a:p>
+          <a:p>
+            <a:pPr>
+              <a:spcAft>
+                <a:spcPts val="1200"/>
+              </a:spcAft>
+              <a:defRPr sz="2200">
+                <a:solidFill>
+                  <a:srgbClr val="1E293B"/>
+                </a:solidFill>
+              </a:defRPr>
+            </a:pPr>
+            <a:r>
+              <a:t>• 13 компетенций</a:t>
+            </a:r>
+          </a:p>
+          <a:p>
+            <a:pPr>
+              <a:spcAft>
+                <a:spcPts val="1200"/>
+              </a:spcAft>
+              <a:defRPr sz="2200">
+                <a:solidFill>
+                  <a:srgbClr val="1E293B"/>
+                </a:solidFill>
+              </a:defRPr>
+            </a:pPr>
+            <a:r>
+              <a:t>• 7 подразделений</a:t>
+            </a:r>
+          </a:p>
+        </p:txBody>
+      </p:sp>
     </p:spTree>
   </p:cSld>
   <p:clrMapOvr>
@@ -3386,6 +3790,14 @@
 <file path=ppt/slides/slide5.xml><?xml version="1.0" encoding="utf-8"?>
 <p:sld xmlns:a="http://schemas.openxmlformats.org/drawingml/2006/main" xmlns:p="http://schemas.openxmlformats.org/presentationml/2006/main" xmlns:r="http://schemas.openxmlformats.org/officeDocument/2006/relationships">
   <p:cSld>
+    <p:bg>
+      <p:bgPr>
+        <a:solidFill>
+          <a:srgbClr val="F8FAFC"/>
+        </a:solidFill>
+        <a:effectLst/>
+      </p:bgPr>
+    </p:bg>
     <p:spTree>
       <p:nvGrpSpPr>
         <p:cNvPr id="1" name=""/>
@@ -3393,30 +3805,186 @@
         <p:nvPr/>
       </p:nvGrpSpPr>
       <p:grpSpPr/>
-      <p:pic>
-        <p:nvPicPr>
-          <p:cNvPr id="2" name="Picture 1" descr="slide_05_portal_structure.png"/>
-          <p:cNvPicPr>
-            <a:picLocks noChangeAspect="1"/>
-          </p:cNvPicPr>
+      <p:sp>
+        <p:nvSpPr>
+          <p:cNvPr id="2" name="Rectangle 1"/>
+          <p:cNvSpPr/>
           <p:nvPr/>
-        </p:nvPicPr>
-        <p:blipFill>
-          <a:blip r:embed="rId2"/>
-          <a:stretch>
-            <a:fillRect/>
-          </a:stretch>
-        </p:blipFill>
+        </p:nvSpPr>
         <p:spPr>
           <a:xfrm>
-            <a:off x="0" y="0"/>
-            <a:ext cx="12191695" cy="6858000"/>
+            <a:off x="502920" y="502920"/>
+            <a:ext cx="11155680" cy="777240"/>
           </a:xfrm>
           <a:prstGeom prst="rect">
             <a:avLst/>
           </a:prstGeom>
+          <a:solidFill>
+            <a:srgbClr val="0F172A"/>
+          </a:solidFill>
+          <a:ln>
+            <a:noFill/>
+          </a:ln>
         </p:spPr>
-      </p:pic>
+        <p:style>
+          <a:lnRef idx="1">
+            <a:schemeClr val="accent1"/>
+          </a:lnRef>
+          <a:fillRef idx="3">
+            <a:schemeClr val="accent1"/>
+          </a:fillRef>
+          <a:effectRef idx="2">
+            <a:schemeClr val="accent1"/>
+          </a:effectRef>
+          <a:fontRef idx="minor">
+            <a:schemeClr val="lt1"/>
+          </a:fontRef>
+        </p:style>
+        <p:txBody>
+          <a:bodyPr rtlCol="0" anchor="ctr"/>
+          <a:lstStyle/>
+          <a:p>
+            <a:pPr>
+              <a:defRPr sz="2700" b="1">
+                <a:solidFill>
+                  <a:srgbClr val="FFFFFF"/>
+                </a:solidFill>
+              </a:defRPr>
+            </a:pPr>
+            <a:r>
+              <a:t>Разделы портала</a:t>
+            </a:r>
+          </a:p>
+        </p:txBody>
+      </p:sp>
+      <p:sp>
+        <p:nvSpPr>
+          <p:cNvPr id="3" name="TextBox 2"/>
+          <p:cNvSpPr txBox="1"/>
+          <p:nvPr/>
+        </p:nvSpPr>
+        <p:spPr>
+          <a:xfrm>
+            <a:off x="731520" y="1600200"/>
+            <a:ext cx="10698480" cy="4389120"/>
+          </a:xfrm>
+          <a:prstGeom prst="rect">
+            <a:avLst/>
+          </a:prstGeom>
+          <a:noFill/>
+        </p:spPr>
+        <p:txBody>
+          <a:bodyPr wrap="square">
+            <a:spAutoFit/>
+          </a:bodyPr>
+          <a:lstStyle/>
+          <a:p>
+            <a:pPr>
+              <a:spcAft>
+                <a:spcPts val="1200"/>
+              </a:spcAft>
+              <a:defRPr sz="2200">
+                <a:solidFill>
+                  <a:srgbClr val="1E293B"/>
+                </a:solidFill>
+              </a:defRPr>
+            </a:pPr>
+            <a:r>
+              <a:t>Сводная панель</a:t>
+            </a:r>
+          </a:p>
+          <a:p>
+            <a:pPr>
+              <a:spcAft>
+                <a:spcPts val="1200"/>
+              </a:spcAft>
+              <a:defRPr sz="2200">
+                <a:solidFill>
+                  <a:srgbClr val="1E293B"/>
+                </a:solidFill>
+              </a:defRPr>
+            </a:pPr>
+            <a:r>
+              <a:t>Учебные планы и дисциплины</a:t>
+            </a:r>
+          </a:p>
+          <a:p>
+            <a:pPr>
+              <a:spcAft>
+                <a:spcPts val="1200"/>
+              </a:spcAft>
+              <a:defRPr sz="2200">
+                <a:solidFill>
+                  <a:srgbClr val="1E293B"/>
+                </a:solidFill>
+              </a:defRPr>
+            </a:pPr>
+            <a:r>
+              <a:t>Проверка ФГОС</a:t>
+            </a:r>
+          </a:p>
+          <a:p>
+            <a:pPr>
+              <a:spcAft>
+                <a:spcPts val="1200"/>
+              </a:spcAft>
+              <a:defRPr sz="2200">
+                <a:solidFill>
+                  <a:srgbClr val="1E293B"/>
+                </a:solidFill>
+              </a:defRPr>
+            </a:pPr>
+            <a:r>
+              <a:t>Согласование</a:t>
+            </a:r>
+          </a:p>
+          <a:p>
+            <a:pPr>
+              <a:spcAft>
+                <a:spcPts val="1200"/>
+              </a:spcAft>
+              <a:defRPr sz="2200">
+                <a:solidFill>
+                  <a:srgbClr val="1E293B"/>
+                </a:solidFill>
+              </a:defRPr>
+            </a:pPr>
+            <a:r>
+              <a:t>Служебные записки</a:t>
+            </a:r>
+          </a:p>
+          <a:p>
+            <a:pPr>
+              <a:spcAft>
+                <a:spcPts val="1200"/>
+              </a:spcAft>
+              <a:defRPr sz="2200">
+                <a:solidFill>
+                  <a:srgbClr val="1E293B"/>
+                </a:solidFill>
+              </a:defRPr>
+            </a:pPr>
+            <a:r>
+              <a:t>Программы, стандарты, компетенции</a:t>
+            </a:r>
+          </a:p>
+          <a:p>
+            <a:pPr>
+              <a:spcAft>
+                <a:spcPts val="1200"/>
+              </a:spcAft>
+              <a:defRPr sz="2200">
+                <a:solidFill>
+                  <a:srgbClr val="1E293B"/>
+                </a:solidFill>
+              </a:defRPr>
+            </a:pPr>
+            <a:r>
+              <a:t>Подразделения, объявления, аудит</a:t>
+            </a:r>
+          </a:p>
+        </p:txBody>
+      </p:sp>
     </p:spTree>
   </p:cSld>
   <p:clrMapOvr>
@@ -3428,6 +3996,14 @@
 <file path=ppt/slides/slide6.xml><?xml version="1.0" encoding="utf-8"?>
 <p:sld xmlns:a="http://schemas.openxmlformats.org/drawingml/2006/main" xmlns:p="http://schemas.openxmlformats.org/presentationml/2006/main" xmlns:r="http://schemas.openxmlformats.org/officeDocument/2006/relationships">
   <p:cSld>
+    <p:bg>
+      <p:bgPr>
+        <a:solidFill>
+          <a:srgbClr val="F8FAFC"/>
+        </a:solidFill>
+        <a:effectLst/>
+      </p:bgPr>
+    </p:bg>
     <p:spTree>
       <p:nvGrpSpPr>
         <p:cNvPr id="1" name=""/>
@@ -3435,30 +4011,123 @@
         <p:nvPr/>
       </p:nvGrpSpPr>
       <p:grpSpPr/>
-      <p:pic>
-        <p:nvPicPr>
-          <p:cNvPr id="2" name="Picture 1" descr="slide_06_fgos_validation.png"/>
-          <p:cNvPicPr>
-            <a:picLocks noChangeAspect="1"/>
-          </p:cNvPicPr>
+      <p:sp>
+        <p:nvSpPr>
+          <p:cNvPr id="2" name="Rectangle 1"/>
+          <p:cNvSpPr/>
           <p:nvPr/>
-        </p:nvPicPr>
-        <p:blipFill>
-          <a:blip r:embed="rId2"/>
-          <a:stretch>
-            <a:fillRect/>
-          </a:stretch>
-        </p:blipFill>
+        </p:nvSpPr>
         <p:spPr>
           <a:xfrm>
-            <a:off x="0" y="0"/>
-            <a:ext cx="12191695" cy="6858000"/>
+            <a:off x="502920" y="502920"/>
+            <a:ext cx="11155680" cy="777240"/>
           </a:xfrm>
           <a:prstGeom prst="rect">
             <a:avLst/>
           </a:prstGeom>
+          <a:solidFill>
+            <a:srgbClr val="0F172A"/>
+          </a:solidFill>
+          <a:ln>
+            <a:noFill/>
+          </a:ln>
         </p:spPr>
-      </p:pic>
+        <p:style>
+          <a:lnRef idx="1">
+            <a:schemeClr val="accent1"/>
+          </a:lnRef>
+          <a:fillRef idx="3">
+            <a:schemeClr val="accent1"/>
+          </a:fillRef>
+          <a:effectRef idx="2">
+            <a:schemeClr val="accent1"/>
+          </a:effectRef>
+          <a:fontRef idx="minor">
+            <a:schemeClr val="lt1"/>
+          </a:fontRef>
+        </p:style>
+        <p:txBody>
+          <a:bodyPr rtlCol="0" anchor="ctr"/>
+          <a:lstStyle/>
+          <a:p>
+            <a:pPr>
+              <a:defRPr sz="2700" b="1">
+                <a:solidFill>
+                  <a:srgbClr val="FFFFFF"/>
+                </a:solidFill>
+              </a:defRPr>
+            </a:pPr>
+            <a:r>
+              <a:t>Работа с учебным планом</a:t>
+            </a:r>
+          </a:p>
+        </p:txBody>
+      </p:sp>
+      <p:sp>
+        <p:nvSpPr>
+          <p:cNvPr id="3" name="TextBox 2"/>
+          <p:cNvSpPr txBox="1"/>
+          <p:nvPr/>
+        </p:nvSpPr>
+        <p:spPr>
+          <a:xfrm>
+            <a:off x="731520" y="1600200"/>
+            <a:ext cx="10698480" cy="4389120"/>
+          </a:xfrm>
+          <a:prstGeom prst="rect">
+            <a:avLst/>
+          </a:prstGeom>
+          <a:noFill/>
+        </p:spPr>
+        <p:txBody>
+          <a:bodyPr wrap="square">
+            <a:spAutoFit/>
+          </a:bodyPr>
+          <a:lstStyle/>
+          <a:p>
+            <a:pPr>
+              <a:spcAft>
+                <a:spcPts val="1200"/>
+              </a:spcAft>
+              <a:defRPr sz="2200">
+                <a:solidFill>
+                  <a:srgbClr val="1E293B"/>
+                </a:solidFill>
+              </a:defRPr>
+            </a:pPr>
+            <a:r>
+              <a:t>Пользователь открывает реестр, выбирает план и просматривает дисциплины по семестрам.</a:t>
+            </a:r>
+          </a:p>
+          <a:p>
+            <a:pPr>
+              <a:spcAft>
+                <a:spcPts val="1200"/>
+              </a:spcAft>
+              <a:defRPr sz="2200">
+                <a:solidFill>
+                  <a:srgbClr val="1E293B"/>
+                </a:solidFill>
+              </a:defRPr>
+            </a:pPr>
+          </a:p>
+          <a:p>
+            <a:pPr>
+              <a:spcAft>
+                <a:spcPts val="1200"/>
+              </a:spcAft>
+              <a:defRPr sz="2200">
+                <a:solidFill>
+                  <a:srgbClr val="1E293B"/>
+                </a:solidFill>
+              </a:defRPr>
+            </a:pPr>
+            <a:r>
+              <a:t>На странице отображаются статус, версия, трудоёмкость, часы и форма контроля.</a:t>
+            </a:r>
+          </a:p>
+        </p:txBody>
+      </p:sp>
     </p:spTree>
   </p:cSld>
   <p:clrMapOvr>
@@ -3470,6 +4139,14 @@
 <file path=ppt/slides/slide7.xml><?xml version="1.0" encoding="utf-8"?>
 <p:sld xmlns:a="http://schemas.openxmlformats.org/drawingml/2006/main" xmlns:p="http://schemas.openxmlformats.org/presentationml/2006/main" xmlns:r="http://schemas.openxmlformats.org/officeDocument/2006/relationships">
   <p:cSld>
+    <p:bg>
+      <p:bgPr>
+        <a:solidFill>
+          <a:srgbClr val="F8FAFC"/>
+        </a:solidFill>
+        <a:effectLst/>
+      </p:bgPr>
+    </p:bg>
     <p:spTree>
       <p:nvGrpSpPr>
         <p:cNvPr id="1" name=""/>
@@ -3477,30 +4154,195 @@
         <p:nvPr/>
       </p:nvGrpSpPr>
       <p:grpSpPr/>
-      <p:pic>
-        <p:nvPicPr>
-          <p:cNvPr id="2" name="Picture 1" descr="slide_07_visual_diff.png"/>
-          <p:cNvPicPr>
-            <a:picLocks noChangeAspect="1"/>
-          </p:cNvPicPr>
+      <p:sp>
+        <p:nvSpPr>
+          <p:cNvPr id="2" name="Rectangle 1"/>
+          <p:cNvSpPr/>
           <p:nvPr/>
-        </p:nvPicPr>
-        <p:blipFill>
-          <a:blip r:embed="rId2"/>
-          <a:stretch>
-            <a:fillRect/>
-          </a:stretch>
-        </p:blipFill>
+        </p:nvSpPr>
         <p:spPr>
           <a:xfrm>
-            <a:off x="0" y="0"/>
-            <a:ext cx="12191695" cy="6858000"/>
+            <a:off x="502920" y="502920"/>
+            <a:ext cx="11155680" cy="777240"/>
           </a:xfrm>
           <a:prstGeom prst="rect">
             <a:avLst/>
           </a:prstGeom>
+          <a:solidFill>
+            <a:srgbClr val="0F172A"/>
+          </a:solidFill>
+          <a:ln>
+            <a:noFill/>
+          </a:ln>
         </p:spPr>
-      </p:pic>
+        <p:style>
+          <a:lnRef idx="1">
+            <a:schemeClr val="accent1"/>
+          </a:lnRef>
+          <a:fillRef idx="3">
+            <a:schemeClr val="accent1"/>
+          </a:fillRef>
+          <a:effectRef idx="2">
+            <a:schemeClr val="accent1"/>
+          </a:effectRef>
+          <a:fontRef idx="minor">
+            <a:schemeClr val="lt1"/>
+          </a:fontRef>
+        </p:style>
+        <p:txBody>
+          <a:bodyPr rtlCol="0" anchor="ctr"/>
+          <a:lstStyle/>
+          <a:p>
+            <a:pPr>
+              <a:defRPr sz="2700" b="1">
+                <a:solidFill>
+                  <a:srgbClr val="FFFFFF"/>
+                </a:solidFill>
+              </a:defRPr>
+            </a:pPr>
+            <a:r>
+              <a:t>Запуск и проверка</a:t>
+            </a:r>
+          </a:p>
+        </p:txBody>
+      </p:sp>
+      <p:sp>
+        <p:nvSpPr>
+          <p:cNvPr id="3" name="TextBox 2"/>
+          <p:cNvSpPr txBox="1"/>
+          <p:nvPr/>
+        </p:nvSpPr>
+        <p:spPr>
+          <a:xfrm>
+            <a:off x="731520" y="1600200"/>
+            <a:ext cx="10698480" cy="4389120"/>
+          </a:xfrm>
+          <a:prstGeom prst="rect">
+            <a:avLst/>
+          </a:prstGeom>
+          <a:noFill/>
+        </p:spPr>
+        <p:txBody>
+          <a:bodyPr wrap="square">
+            <a:spAutoFit/>
+          </a:bodyPr>
+          <a:lstStyle/>
+          <a:p>
+            <a:pPr>
+              <a:spcAft>
+                <a:spcPts val="1200"/>
+              </a:spcAft>
+              <a:defRPr sz="2200">
+                <a:solidFill>
+                  <a:srgbClr val="1E293B"/>
+                </a:solidFill>
+              </a:defRPr>
+            </a:pPr>
+            <a:r>
+              <a:t>Установка:</a:t>
+            </a:r>
+          </a:p>
+          <a:p>
+            <a:pPr>
+              <a:spcAft>
+                <a:spcPts val="1200"/>
+              </a:spcAft>
+              <a:defRPr sz="2200">
+                <a:solidFill>
+                  <a:srgbClr val="1E293B"/>
+                </a:solidFill>
+              </a:defRPr>
+            </a:pPr>
+            <a:r>
+              <a:t>python -m pip install -r requirements.txt</a:t>
+            </a:r>
+          </a:p>
+          <a:p>
+            <a:pPr>
+              <a:spcAft>
+                <a:spcPts val="1200"/>
+              </a:spcAft>
+              <a:defRPr sz="2200">
+                <a:solidFill>
+                  <a:srgbClr val="1E293B"/>
+                </a:solidFill>
+              </a:defRPr>
+            </a:pPr>
+          </a:p>
+          <a:p>
+            <a:pPr>
+              <a:spcAft>
+                <a:spcPts val="1200"/>
+              </a:spcAft>
+              <a:defRPr sz="2200">
+                <a:solidFill>
+                  <a:srgbClr val="1E293B"/>
+                </a:solidFill>
+              </a:defRPr>
+            </a:pPr>
+            <a:r>
+              <a:t>Запуск:</a:t>
+            </a:r>
+          </a:p>
+          <a:p>
+            <a:pPr>
+              <a:spcAft>
+                <a:spcPts val="1200"/>
+              </a:spcAft>
+              <a:defRPr sz="2200">
+                <a:solidFill>
+                  <a:srgbClr val="1E293B"/>
+                </a:solidFill>
+              </a:defRPr>
+            </a:pPr>
+            <a:r>
+              <a:t>python -m portal.app</a:t>
+            </a:r>
+          </a:p>
+          <a:p>
+            <a:pPr>
+              <a:spcAft>
+                <a:spcPts val="1200"/>
+              </a:spcAft>
+              <a:defRPr sz="2200">
+                <a:solidFill>
+                  <a:srgbClr val="1E293B"/>
+                </a:solidFill>
+              </a:defRPr>
+            </a:pPr>
+          </a:p>
+          <a:p>
+            <a:pPr>
+              <a:spcAft>
+                <a:spcPts val="1200"/>
+              </a:spcAft>
+              <a:defRPr sz="2200">
+                <a:solidFill>
+                  <a:srgbClr val="1E293B"/>
+                </a:solidFill>
+              </a:defRPr>
+            </a:pPr>
+            <a:r>
+              <a:t>Адрес:</a:t>
+            </a:r>
+          </a:p>
+          <a:p>
+            <a:pPr>
+              <a:spcAft>
+                <a:spcPts val="1200"/>
+              </a:spcAft>
+              <a:defRPr sz="2200">
+                <a:solidFill>
+                  <a:srgbClr val="1E293B"/>
+                </a:solidFill>
+              </a:defRPr>
+            </a:pPr>
+            <a:r>
+              <a:t>http://127.0.0.1:5000</a:t>
+            </a:r>
+          </a:p>
+        </p:txBody>
+      </p:sp>
     </p:spTree>
   </p:cSld>
   <p:clrMapOvr>
@@ -3512,6 +4354,14 @@
 <file path=ppt/slides/slide8.xml><?xml version="1.0" encoding="utf-8"?>
 <p:sld xmlns:a="http://schemas.openxmlformats.org/drawingml/2006/main" xmlns:p="http://schemas.openxmlformats.org/presentationml/2006/main" xmlns:r="http://schemas.openxmlformats.org/officeDocument/2006/relationships">
   <p:cSld>
+    <p:bg>
+      <p:bgPr>
+        <a:solidFill>
+          <a:srgbClr val="F8FAFC"/>
+        </a:solidFill>
+        <a:effectLst/>
+      </p:bgPr>
+    </p:bg>
     <p:spTree>
       <p:nvGrpSpPr>
         <p:cNvPr id="1" name=""/>
@@ -3519,30 +4369,186 @@
         <p:nvPr/>
       </p:nvGrpSpPr>
       <p:grpSpPr/>
-      <p:pic>
-        <p:nvPicPr>
-          <p:cNvPr id="2" name="Picture 1" descr="slide_08_crypto_signature.png"/>
-          <p:cNvPicPr>
-            <a:picLocks noChangeAspect="1"/>
-          </p:cNvPicPr>
+      <p:sp>
+        <p:nvSpPr>
+          <p:cNvPr id="2" name="Rectangle 1"/>
+          <p:cNvSpPr/>
           <p:nvPr/>
-        </p:nvPicPr>
-        <p:blipFill>
-          <a:blip r:embed="rId2"/>
-          <a:stretch>
-            <a:fillRect/>
-          </a:stretch>
-        </p:blipFill>
+        </p:nvSpPr>
         <p:spPr>
           <a:xfrm>
-            <a:off x="0" y="0"/>
-            <a:ext cx="12191695" cy="6858000"/>
+            <a:off x="502920" y="502920"/>
+            <a:ext cx="11155680" cy="777240"/>
           </a:xfrm>
           <a:prstGeom prst="rect">
             <a:avLst/>
           </a:prstGeom>
+          <a:solidFill>
+            <a:srgbClr val="0F172A"/>
+          </a:solidFill>
+          <a:ln>
+            <a:noFill/>
+          </a:ln>
         </p:spPr>
-      </p:pic>
+        <p:style>
+          <a:lnRef idx="1">
+            <a:schemeClr val="accent1"/>
+          </a:lnRef>
+          <a:fillRef idx="3">
+            <a:schemeClr val="accent1"/>
+          </a:fillRef>
+          <a:effectRef idx="2">
+            <a:schemeClr val="accent1"/>
+          </a:effectRef>
+          <a:fontRef idx="minor">
+            <a:schemeClr val="lt1"/>
+          </a:fontRef>
+        </p:style>
+        <p:txBody>
+          <a:bodyPr rtlCol="0" anchor="ctr"/>
+          <a:lstStyle/>
+          <a:p>
+            <a:pPr>
+              <a:defRPr sz="2700" b="1">
+                <a:solidFill>
+                  <a:srgbClr val="FFFFFF"/>
+                </a:solidFill>
+              </a:defRPr>
+            </a:pPr>
+            <a:r>
+              <a:t>Ограничения прототипа</a:t>
+            </a:r>
+          </a:p>
+        </p:txBody>
+      </p:sp>
+      <p:sp>
+        <p:nvSpPr>
+          <p:cNvPr id="3" name="TextBox 2"/>
+          <p:cNvSpPr txBox="1"/>
+          <p:nvPr/>
+        </p:nvSpPr>
+        <p:spPr>
+          <a:xfrm>
+            <a:off x="731520" y="1600200"/>
+            <a:ext cx="10698480" cy="4389120"/>
+          </a:xfrm>
+          <a:prstGeom prst="rect">
+            <a:avLst/>
+          </a:prstGeom>
+          <a:noFill/>
+        </p:spPr>
+        <p:txBody>
+          <a:bodyPr wrap="square">
+            <a:spAutoFit/>
+          </a:bodyPr>
+          <a:lstStyle/>
+          <a:p>
+            <a:pPr>
+              <a:spcAft>
+                <a:spcPts val="1200"/>
+              </a:spcAft>
+              <a:defRPr sz="1900">
+                <a:solidFill>
+                  <a:srgbClr val="1E293B"/>
+                </a:solidFill>
+              </a:defRPr>
+            </a:pPr>
+            <a:r>
+              <a:t>Не реализованы:</a:t>
+            </a:r>
+          </a:p>
+          <a:p>
+            <a:pPr>
+              <a:spcAft>
+                <a:spcPts val="1200"/>
+              </a:spcAft>
+              <a:defRPr sz="1900">
+                <a:solidFill>
+                  <a:srgbClr val="1E293B"/>
+                </a:solidFill>
+              </a:defRPr>
+            </a:pPr>
+            <a:r>
+              <a:t>• авторизация и проверка ролей;</a:t>
+            </a:r>
+          </a:p>
+          <a:p>
+            <a:pPr>
+              <a:spcAft>
+                <a:spcPts val="1200"/>
+              </a:spcAft>
+              <a:defRPr sz="1900">
+                <a:solidFill>
+                  <a:srgbClr val="1E293B"/>
+                </a:solidFill>
+              </a:defRPr>
+            </a:pPr>
+            <a:r>
+              <a:t>• редактирование через формы;</a:t>
+            </a:r>
+          </a:p>
+          <a:p>
+            <a:pPr>
+              <a:spcAft>
+                <a:spcPts val="1200"/>
+              </a:spcAft>
+              <a:defRPr sz="1900">
+                <a:solidFill>
+                  <a:srgbClr val="1E293B"/>
+                </a:solidFill>
+              </a:defRPr>
+            </a:pPr>
+            <a:r>
+              <a:t>• полноценный движок проверки ФГОС;</a:t>
+            </a:r>
+          </a:p>
+          <a:p>
+            <a:pPr>
+              <a:spcAft>
+                <a:spcPts val="1200"/>
+              </a:spcAft>
+              <a:defRPr sz="1900">
+                <a:solidFill>
+                  <a:srgbClr val="1E293B"/>
+                </a:solidFill>
+              </a:defRPr>
+            </a:pPr>
+            <a:r>
+              <a:t>• квалифицированная ЭЦП;</a:t>
+            </a:r>
+          </a:p>
+          <a:p>
+            <a:pPr>
+              <a:spcAft>
+                <a:spcPts val="1200"/>
+              </a:spcAft>
+              <a:defRPr sz="1900">
+                <a:solidFill>
+                  <a:srgbClr val="1E293B"/>
+                </a:solidFill>
+              </a:defRPr>
+            </a:pPr>
+            <a:r>
+              <a:t>• экспорт PDF/Excel;</a:t>
+            </a:r>
+          </a:p>
+          <a:p>
+            <a:pPr>
+              <a:spcAft>
+                <a:spcPts val="1200"/>
+              </a:spcAft>
+              <a:defRPr sz="1900">
+                <a:solidFill>
+                  <a:srgbClr val="1E293B"/>
+                </a:solidFill>
+              </a:defRPr>
+            </a:pPr>
+            <a:r>
+              <a:t>• внешние интеграции.</a:t>
+            </a:r>
+          </a:p>
+        </p:txBody>
+      </p:sp>
     </p:spTree>
   </p:cSld>
   <p:clrMapOvr>
@@ -3554,6 +4560,14 @@
 <file path=ppt/slides/slide9.xml><?xml version="1.0" encoding="utf-8"?>
 <p:sld xmlns:a="http://schemas.openxmlformats.org/drawingml/2006/main" xmlns:p="http://schemas.openxmlformats.org/presentationml/2006/main" xmlns:r="http://schemas.openxmlformats.org/officeDocument/2006/relationships">
   <p:cSld>
+    <p:bg>
+      <p:bgPr>
+        <a:solidFill>
+          <a:srgbClr val="F8FAFC"/>
+        </a:solidFill>
+        <a:effectLst/>
+      </p:bgPr>
+    </p:bg>
     <p:spTree>
       <p:nvGrpSpPr>
         <p:cNvPr id="1" name=""/>
@@ -3561,30 +4575,123 @@
         <p:nvPr/>
       </p:nvGrpSpPr>
       <p:grpSpPr/>
-      <p:pic>
-        <p:nvPicPr>
-          <p:cNvPr id="2" name="Picture 1" descr="slide_09_analytics_export.png"/>
-          <p:cNvPicPr>
-            <a:picLocks noChangeAspect="1"/>
-          </p:cNvPicPr>
+      <p:sp>
+        <p:nvSpPr>
+          <p:cNvPr id="2" name="Rectangle 1"/>
+          <p:cNvSpPr/>
           <p:nvPr/>
-        </p:nvPicPr>
-        <p:blipFill>
-          <a:blip r:embed="rId2"/>
-          <a:stretch>
-            <a:fillRect/>
-          </a:stretch>
-        </p:blipFill>
+        </p:nvSpPr>
         <p:spPr>
           <a:xfrm>
-            <a:off x="0" y="0"/>
-            <a:ext cx="12191695" cy="6858000"/>
+            <a:off x="502920" y="502920"/>
+            <a:ext cx="11155680" cy="777240"/>
           </a:xfrm>
           <a:prstGeom prst="rect">
             <a:avLst/>
           </a:prstGeom>
+          <a:solidFill>
+            <a:srgbClr val="0F172A"/>
+          </a:solidFill>
+          <a:ln>
+            <a:noFill/>
+          </a:ln>
         </p:spPr>
-      </p:pic>
+        <p:style>
+          <a:lnRef idx="1">
+            <a:schemeClr val="accent1"/>
+          </a:lnRef>
+          <a:fillRef idx="3">
+            <a:schemeClr val="accent1"/>
+          </a:fillRef>
+          <a:effectRef idx="2">
+            <a:schemeClr val="accent1"/>
+          </a:effectRef>
+          <a:fontRef idx="minor">
+            <a:schemeClr val="lt1"/>
+          </a:fontRef>
+        </p:style>
+        <p:txBody>
+          <a:bodyPr rtlCol="0" anchor="ctr"/>
+          <a:lstStyle/>
+          <a:p>
+            <a:pPr>
+              <a:defRPr sz="2700" b="1">
+                <a:solidFill>
+                  <a:srgbClr val="FFFFFF"/>
+                </a:solidFill>
+              </a:defRPr>
+            </a:pPr>
+            <a:r>
+              <a:t>Итог</a:t>
+            </a:r>
+          </a:p>
+        </p:txBody>
+      </p:sp>
+      <p:sp>
+        <p:nvSpPr>
+          <p:cNvPr id="3" name="TextBox 2"/>
+          <p:cNvSpPr txBox="1"/>
+          <p:nvPr/>
+        </p:nvSpPr>
+        <p:spPr>
+          <a:xfrm>
+            <a:off x="731520" y="1600200"/>
+            <a:ext cx="10698480" cy="4389120"/>
+          </a:xfrm>
+          <a:prstGeom prst="rect">
+            <a:avLst/>
+          </a:prstGeom>
+          <a:noFill/>
+        </p:spPr>
+        <p:txBody>
+          <a:bodyPr wrap="square">
+            <a:spAutoFit/>
+          </a:bodyPr>
+          <a:lstStyle/>
+          <a:p>
+            <a:pPr>
+              <a:spcAft>
+                <a:spcPts val="1200"/>
+              </a:spcAft>
+              <a:defRPr sz="2200">
+                <a:solidFill>
+                  <a:srgbClr val="1E293B"/>
+                </a:solidFill>
+              </a:defRPr>
+            </a:pPr>
+            <a:r>
+              <a:t>Подготовлен запускаемый локальный прототип портала АНОК.</a:t>
+            </a:r>
+          </a:p>
+          <a:p>
+            <a:pPr>
+              <a:spcAft>
+                <a:spcPts val="1200"/>
+              </a:spcAft>
+              <a:defRPr sz="2200">
+                <a:solidFill>
+                  <a:srgbClr val="1E293B"/>
+                </a:solidFill>
+              </a:defRPr>
+            </a:pPr>
+          </a:p>
+          <a:p>
+            <a:pPr>
+              <a:spcAft>
+                <a:spcPts val="1200"/>
+              </a:spcAft>
+              <a:defRPr sz="2200">
+                <a:solidFill>
+                  <a:srgbClr val="1E293B"/>
+                </a:solidFill>
+              </a:defRPr>
+            </a:pPr>
+            <a:r>
+              <a:t>Документация и презентация описывают только фактически реализованные возможности.</a:t>
+            </a:r>
+          </a:p>
+        </p:txBody>
+      </p:sp>
     </p:spTree>
   </p:cSld>
   <p:clrMapOvr>

</xml_diff>

<commit_message>
Migrate portal implementation to PHP and MySQL
Co-authored-by: arena-agent <297053741+arena-agent@users.noreply.github.com>
</commit_message>
<xml_diff>
--- a/reports/lab7/LR7_Presentation_Variant15.pptx
+++ b/reports/lab7/LR7_Presentation_Variant15.pptx
@@ -13,10 +13,6 @@
     <p:sldId id="261" r:id="rId12"/>
     <p:sldId id="262" r:id="rId13"/>
     <p:sldId id="263" r:id="rId14"/>
-    <p:sldId id="264" r:id="rId15"/>
-    <p:sldId id="265" r:id="rId16"/>
-    <p:sldId id="266" r:id="rId17"/>
-    <p:sldId id="267" r:id="rId18"/>
   </p:sldIdLst>
   <p:sldSz cx="12191695" cy="6858000" type="screen4x3"/>
   <p:notesSz cx="6858000" cy="9144000"/>
@@ -3092,6 +3088,14 @@
 <file path=ppt/slides/slide1.xml><?xml version="1.0" encoding="utf-8"?>
 <p:sld xmlns:a="http://schemas.openxmlformats.org/drawingml/2006/main" xmlns:p="http://schemas.openxmlformats.org/presentationml/2006/main" xmlns:r="http://schemas.openxmlformats.org/officeDocument/2006/relationships">
   <p:cSld>
+    <p:bg>
+      <p:bgPr>
+        <a:solidFill>
+          <a:srgbClr val="F8FAFC"/>
+        </a:solidFill>
+        <a:effectLst/>
+      </p:bgPr>
+    </p:bg>
     <p:spTree>
       <p:nvGrpSpPr>
         <p:cNvPr id="1" name=""/>
@@ -3099,156 +3103,126 @@
         <p:nvPr/>
       </p:nvGrpSpPr>
       <p:grpSpPr/>
-      <p:pic>
-        <p:nvPicPr>
-          <p:cNvPr id="2" name="Picture 1" descr="slide_01_title.png"/>
-          <p:cNvPicPr>
-            <a:picLocks noChangeAspect="1"/>
-          </p:cNvPicPr>
+      <p:sp>
+        <p:nvSpPr>
+          <p:cNvPr id="2" name="Rectangle 1"/>
+          <p:cNvSpPr/>
           <p:nvPr/>
-        </p:nvPicPr>
-        <p:blipFill>
-          <a:blip r:embed="rId2"/>
-          <a:stretch>
-            <a:fillRect/>
-          </a:stretch>
-        </p:blipFill>
+        </p:nvSpPr>
         <p:spPr>
           <a:xfrm>
-            <a:off x="0" y="0"/>
-            <a:ext cx="12191695" cy="6858000"/>
+            <a:off x="457200" y="457200"/>
+            <a:ext cx="11247120" cy="731520"/>
           </a:xfrm>
           <a:prstGeom prst="rect">
             <a:avLst/>
           </a:prstGeom>
+          <a:solidFill>
+            <a:srgbClr val="0F172A"/>
+          </a:solidFill>
+          <a:ln>
+            <a:noFill/>
+          </a:ln>
         </p:spPr>
-      </p:pic>
-    </p:spTree>
-  </p:cSld>
-  <p:clrMapOvr>
-    <a:masterClrMapping/>
-  </p:clrMapOvr>
-</p:sld>
-</file>
-
-<file path=ppt/slides/slide10.xml><?xml version="1.0" encoding="utf-8"?>
-<p:sld xmlns:a="http://schemas.openxmlformats.org/drawingml/2006/main" xmlns:p="http://schemas.openxmlformats.org/presentationml/2006/main" xmlns:r="http://schemas.openxmlformats.org/officeDocument/2006/relationships">
-  <p:cSld>
-    <p:spTree>
-      <p:nvGrpSpPr>
-        <p:cNvPr id="1" name=""/>
-        <p:cNvGrpSpPr/>
-        <p:nvPr/>
-      </p:nvGrpSpPr>
-      <p:grpSpPr/>
-      <p:pic>
-        <p:nvPicPr>
-          <p:cNvPr id="2" name="Picture 1" descr="slide_10_interactive_ux.png"/>
-          <p:cNvPicPr>
-            <a:picLocks noChangeAspect="1"/>
-          </p:cNvPicPr>
+        <p:style>
+          <a:lnRef idx="1">
+            <a:schemeClr val="accent1"/>
+          </a:lnRef>
+          <a:fillRef idx="3">
+            <a:schemeClr val="accent1"/>
+          </a:fillRef>
+          <a:effectRef idx="2">
+            <a:schemeClr val="accent1"/>
+          </a:effectRef>
+          <a:fontRef idx="minor">
+            <a:schemeClr val="lt1"/>
+          </a:fontRef>
+        </p:style>
+        <p:txBody>
+          <a:bodyPr rtlCol="0" anchor="ctr"/>
+          <a:lstStyle/>
+          <a:p>
+            <a:pPr>
+              <a:defRPr sz="2600" b="1">
+                <a:solidFill>
+                  <a:srgbClr val="FFFFFF"/>
+                </a:solidFill>
+              </a:defRPr>
+            </a:pPr>
+            <a:r>
+              <a:t>Портал Центра АНОК</a:t>
+            </a:r>
+          </a:p>
+        </p:txBody>
+      </p:sp>
+      <p:sp>
+        <p:nvSpPr>
+          <p:cNvPr id="3" name="TextBox 2"/>
+          <p:cNvSpPr txBox="1"/>
           <p:nvPr/>
-        </p:nvPicPr>
-        <p:blipFill>
-          <a:blip r:embed="rId2"/>
-          <a:stretch>
-            <a:fillRect/>
-          </a:stretch>
-        </p:blipFill>
+        </p:nvSpPr>
         <p:spPr>
           <a:xfrm>
-            <a:off x="0" y="0"/>
-            <a:ext cx="12191695" cy="6858000"/>
+            <a:off x="731520" y="1554480"/>
+            <a:ext cx="10789920" cy="4572000"/>
           </a:xfrm>
           <a:prstGeom prst="rect">
             <a:avLst/>
           </a:prstGeom>
+          <a:noFill/>
         </p:spPr>
-      </p:pic>
-    </p:spTree>
-  </p:cSld>
-  <p:clrMapOvr>
-    <a:masterClrMapping/>
-  </p:clrMapOvr>
-</p:sld>
-</file>
-
-<file path=ppt/slides/slide11.xml><?xml version="1.0" encoding="utf-8"?>
-<p:sld xmlns:a="http://schemas.openxmlformats.org/drawingml/2006/main" xmlns:p="http://schemas.openxmlformats.org/presentationml/2006/main" xmlns:r="http://schemas.openxmlformats.org/officeDocument/2006/relationships">
-  <p:cSld>
-    <p:spTree>
-      <p:nvGrpSpPr>
-        <p:cNvPr id="1" name=""/>
-        <p:cNvGrpSpPr/>
-        <p:nvPr/>
-      </p:nvGrpSpPr>
-      <p:grpSpPr/>
-      <p:pic>
-        <p:nvPicPr>
-          <p:cNvPr id="2" name="Picture 1" descr="slide_11_testing_security.png"/>
-          <p:cNvPicPr>
-            <a:picLocks noChangeAspect="1"/>
-          </p:cNvPicPr>
-          <p:nvPr/>
-        </p:nvPicPr>
-        <p:blipFill>
-          <a:blip r:embed="rId2"/>
-          <a:stretch>
-            <a:fillRect/>
-          </a:stretch>
-        </p:blipFill>
-        <p:spPr>
-          <a:xfrm>
-            <a:off x="0" y="0"/>
-            <a:ext cx="12191695" cy="6858000"/>
-          </a:xfrm>
-          <a:prstGeom prst="rect">
-            <a:avLst/>
-          </a:prstGeom>
-        </p:spPr>
-      </p:pic>
-    </p:spTree>
-  </p:cSld>
-  <p:clrMapOvr>
-    <a:masterClrMapping/>
-  </p:clrMapOvr>
-</p:sld>
-</file>
-
-<file path=ppt/slides/slide12.xml><?xml version="1.0" encoding="utf-8"?>
-<p:sld xmlns:a="http://schemas.openxmlformats.org/drawingml/2006/main" xmlns:p="http://schemas.openxmlformats.org/presentationml/2006/main" xmlns:r="http://schemas.openxmlformats.org/officeDocument/2006/relationships">
-  <p:cSld>
-    <p:spTree>
-      <p:nvGrpSpPr>
-        <p:cNvPr id="1" name=""/>
-        <p:cNvGrpSpPr/>
-        <p:nvPr/>
-      </p:nvGrpSpPr>
-      <p:grpSpPr/>
-      <p:pic>
-        <p:nvPicPr>
-          <p:cNvPr id="2" name="Picture 1" descr="slide_12_conclusion_impact.png"/>
-          <p:cNvPicPr>
-            <a:picLocks noChangeAspect="1"/>
-          </p:cNvPicPr>
-          <p:nvPr/>
-        </p:nvPicPr>
-        <p:blipFill>
-          <a:blip r:embed="rId2"/>
-          <a:stretch>
-            <a:fillRect/>
-          </a:stretch>
-        </p:blipFill>
-        <p:spPr>
-          <a:xfrm>
-            <a:off x="0" y="0"/>
-            <a:ext cx="12191695" cy="6858000"/>
-          </a:xfrm>
-          <a:prstGeom prst="rect">
-            <a:avLst/>
-          </a:prstGeom>
-        </p:spPr>
-      </p:pic>
+        <p:txBody>
+          <a:bodyPr wrap="none">
+            <a:spAutoFit/>
+          </a:bodyPr>
+          <a:lstStyle/>
+          <a:p>
+            <a:pPr>
+              <a:spcAft>
+                <a:spcPts val="1200"/>
+              </a:spcAft>
+              <a:defRPr sz="2200">
+                <a:solidFill>
+                  <a:srgbClr val="1E293B"/>
+                </a:solidFill>
+              </a:defRPr>
+            </a:pPr>
+            <a:r>
+              <a:t>Учебный прототип</a:t>
+            </a:r>
+          </a:p>
+          <a:p>
+            <a:pPr>
+              <a:spcAft>
+                <a:spcPts val="1200"/>
+              </a:spcAft>
+              <a:defRPr sz="2200">
+                <a:solidFill>
+                  <a:srgbClr val="1E293B"/>
+                </a:solidFill>
+              </a:defRPr>
+            </a:pPr>
+            <a:r>
+              <a:t>Вариант 15 — Университет</a:t>
+            </a:r>
+          </a:p>
+          <a:p>
+            <a:pPr>
+              <a:spcAft>
+                <a:spcPts val="1200"/>
+              </a:spcAft>
+              <a:defRPr sz="2200">
+                <a:solidFill>
+                  <a:srgbClr val="1E293B"/>
+                </a:solidFill>
+              </a:defRPr>
+            </a:pPr>
+            <a:r>
+              <a:t>PHP + MySQL/MariaDB</a:t>
+            </a:r>
+          </a:p>
+        </p:txBody>
+      </p:sp>
     </p:spTree>
   </p:cSld>
   <p:clrMapOvr>
@@ -3260,6 +3234,14 @@
 <file path=ppt/slides/slide2.xml><?xml version="1.0" encoding="utf-8"?>
 <p:sld xmlns:a="http://schemas.openxmlformats.org/drawingml/2006/main" xmlns:p="http://schemas.openxmlformats.org/presentationml/2006/main" xmlns:r="http://schemas.openxmlformats.org/officeDocument/2006/relationships">
   <p:cSld>
+    <p:bg>
+      <p:bgPr>
+        <a:solidFill>
+          <a:srgbClr val="F8FAFC"/>
+        </a:solidFill>
+        <a:effectLst/>
+      </p:bgPr>
+    </p:bg>
     <p:spTree>
       <p:nvGrpSpPr>
         <p:cNvPr id="1" name=""/>
@@ -3267,30 +3249,111 @@
         <p:nvPr/>
       </p:nvGrpSpPr>
       <p:grpSpPr/>
-      <p:pic>
-        <p:nvPicPr>
-          <p:cNvPr id="2" name="Picture 1" descr="slide_02_context_goals.png"/>
-          <p:cNvPicPr>
-            <a:picLocks noChangeAspect="1"/>
-          </p:cNvPicPr>
+      <p:sp>
+        <p:nvSpPr>
+          <p:cNvPr id="2" name="Rectangle 1"/>
+          <p:cNvSpPr/>
           <p:nvPr/>
-        </p:nvPicPr>
-        <p:blipFill>
-          <a:blip r:embed="rId2"/>
-          <a:stretch>
-            <a:fillRect/>
-          </a:stretch>
-        </p:blipFill>
+        </p:nvSpPr>
         <p:spPr>
           <a:xfrm>
-            <a:off x="0" y="0"/>
-            <a:ext cx="12191695" cy="6858000"/>
+            <a:off x="457200" y="457200"/>
+            <a:ext cx="11247120" cy="731520"/>
           </a:xfrm>
           <a:prstGeom prst="rect">
             <a:avLst/>
           </a:prstGeom>
+          <a:solidFill>
+            <a:srgbClr val="0F172A"/>
+          </a:solidFill>
+          <a:ln>
+            <a:noFill/>
+          </a:ln>
         </p:spPr>
-      </p:pic>
+        <p:style>
+          <a:lnRef idx="1">
+            <a:schemeClr val="accent1"/>
+          </a:lnRef>
+          <a:fillRef idx="3">
+            <a:schemeClr val="accent1"/>
+          </a:fillRef>
+          <a:effectRef idx="2">
+            <a:schemeClr val="accent1"/>
+          </a:effectRef>
+          <a:fontRef idx="minor">
+            <a:schemeClr val="lt1"/>
+          </a:fontRef>
+        </p:style>
+        <p:txBody>
+          <a:bodyPr rtlCol="0" anchor="ctr"/>
+          <a:lstStyle/>
+          <a:p>
+            <a:pPr>
+              <a:defRPr sz="2600" b="1">
+                <a:solidFill>
+                  <a:srgbClr val="FFFFFF"/>
+                </a:solidFill>
+              </a:defRPr>
+            </a:pPr>
+            <a:r>
+              <a:t>Назначение</a:t>
+            </a:r>
+          </a:p>
+        </p:txBody>
+      </p:sp>
+      <p:sp>
+        <p:nvSpPr>
+          <p:cNvPr id="3" name="TextBox 2"/>
+          <p:cNvSpPr txBox="1"/>
+          <p:nvPr/>
+        </p:nvSpPr>
+        <p:spPr>
+          <a:xfrm>
+            <a:off x="731520" y="1554480"/>
+            <a:ext cx="10789920" cy="4572000"/>
+          </a:xfrm>
+          <a:prstGeom prst="rect">
+            <a:avLst/>
+          </a:prstGeom>
+          <a:noFill/>
+        </p:spPr>
+        <p:txBody>
+          <a:bodyPr wrap="none">
+            <a:spAutoFit/>
+          </a:bodyPr>
+          <a:lstStyle/>
+          <a:p>
+            <a:pPr>
+              <a:spcAft>
+                <a:spcPts val="1200"/>
+              </a:spcAft>
+              <a:defRPr sz="2200">
+                <a:solidFill>
+                  <a:srgbClr val="1E293B"/>
+                </a:solidFill>
+              </a:defRPr>
+            </a:pPr>
+            <a:r>
+              <a:t>Просмотр учебных планов, дисциплин, стандартов ФГОС, программ и служебных записок.</a:t>
+            </a:r>
+          </a:p>
+          <a:p>
+            <a:pPr>
+              <a:spcAft>
+                <a:spcPts val="1200"/>
+              </a:spcAft>
+              <a:defRPr sz="2200">
+                <a:solidFill>
+                  <a:srgbClr val="1E293B"/>
+                </a:solidFill>
+              </a:defRPr>
+            </a:pPr>
+            <a:r>
+              <a:t>Учебный прототип без промышленного документооборота.</a:t>
+            </a:r>
+          </a:p>
+        </p:txBody>
+      </p:sp>
     </p:spTree>
   </p:cSld>
   <p:clrMapOvr>
@@ -3302,6 +3365,14 @@
 <file path=ppt/slides/slide3.xml><?xml version="1.0" encoding="utf-8"?>
 <p:sld xmlns:a="http://schemas.openxmlformats.org/drawingml/2006/main" xmlns:p="http://schemas.openxmlformats.org/presentationml/2006/main" xmlns:r="http://schemas.openxmlformats.org/officeDocument/2006/relationships">
   <p:cSld>
+    <p:bg>
+      <p:bgPr>
+        <a:solidFill>
+          <a:srgbClr val="F8FAFC"/>
+        </a:solidFill>
+        <a:effectLst/>
+      </p:bgPr>
+    </p:bg>
     <p:spTree>
       <p:nvGrpSpPr>
         <p:cNvPr id="1" name=""/>
@@ -3309,30 +3380,156 @@
         <p:nvPr/>
       </p:nvGrpSpPr>
       <p:grpSpPr/>
-      <p:pic>
-        <p:nvPicPr>
-          <p:cNvPr id="2" name="Picture 1" descr="slide_03_architecture_stack.png"/>
-          <p:cNvPicPr>
-            <a:picLocks noChangeAspect="1"/>
-          </p:cNvPicPr>
+      <p:sp>
+        <p:nvSpPr>
+          <p:cNvPr id="2" name="Rectangle 1"/>
+          <p:cNvSpPr/>
           <p:nvPr/>
-        </p:nvPicPr>
-        <p:blipFill>
-          <a:blip r:embed="rId2"/>
-          <a:stretch>
-            <a:fillRect/>
-          </a:stretch>
-        </p:blipFill>
+        </p:nvSpPr>
         <p:spPr>
           <a:xfrm>
-            <a:off x="0" y="0"/>
-            <a:ext cx="12191695" cy="6858000"/>
+            <a:off x="457200" y="457200"/>
+            <a:ext cx="11247120" cy="731520"/>
           </a:xfrm>
           <a:prstGeom prst="rect">
             <a:avLst/>
           </a:prstGeom>
+          <a:solidFill>
+            <a:srgbClr val="0F172A"/>
+          </a:solidFill>
+          <a:ln>
+            <a:noFill/>
+          </a:ln>
         </p:spPr>
-      </p:pic>
+        <p:style>
+          <a:lnRef idx="1">
+            <a:schemeClr val="accent1"/>
+          </a:lnRef>
+          <a:fillRef idx="3">
+            <a:schemeClr val="accent1"/>
+          </a:fillRef>
+          <a:effectRef idx="2">
+            <a:schemeClr val="accent1"/>
+          </a:effectRef>
+          <a:fontRef idx="minor">
+            <a:schemeClr val="lt1"/>
+          </a:fontRef>
+        </p:style>
+        <p:txBody>
+          <a:bodyPr rtlCol="0" anchor="ctr"/>
+          <a:lstStyle/>
+          <a:p>
+            <a:pPr>
+              <a:defRPr sz="2600" b="1">
+                <a:solidFill>
+                  <a:srgbClr val="FFFFFF"/>
+                </a:solidFill>
+              </a:defRPr>
+            </a:pPr>
+            <a:r>
+              <a:t>Стек</a:t>
+            </a:r>
+          </a:p>
+        </p:txBody>
+      </p:sp>
+      <p:sp>
+        <p:nvSpPr>
+          <p:cNvPr id="3" name="TextBox 2"/>
+          <p:cNvSpPr txBox="1"/>
+          <p:nvPr/>
+        </p:nvSpPr>
+        <p:spPr>
+          <a:xfrm>
+            <a:off x="731520" y="1554480"/>
+            <a:ext cx="10789920" cy="4572000"/>
+          </a:xfrm>
+          <a:prstGeom prst="rect">
+            <a:avLst/>
+          </a:prstGeom>
+          <a:noFill/>
+        </p:spPr>
+        <p:txBody>
+          <a:bodyPr wrap="none">
+            <a:spAutoFit/>
+          </a:bodyPr>
+          <a:lstStyle/>
+          <a:p>
+            <a:pPr>
+              <a:spcAft>
+                <a:spcPts val="1200"/>
+              </a:spcAft>
+              <a:defRPr sz="2200">
+                <a:solidFill>
+                  <a:srgbClr val="1E293B"/>
+                </a:solidFill>
+              </a:defRPr>
+            </a:pPr>
+            <a:r>
+              <a:t>PHP 8.1+</a:t>
+            </a:r>
+          </a:p>
+          <a:p>
+            <a:pPr>
+              <a:spcAft>
+                <a:spcPts val="1200"/>
+              </a:spcAft>
+              <a:defRPr sz="2200">
+                <a:solidFill>
+                  <a:srgbClr val="1E293B"/>
+                </a:solidFill>
+              </a:defRPr>
+            </a:pPr>
+            <a:r>
+              <a:t>PDO MySQL</a:t>
+            </a:r>
+          </a:p>
+          <a:p>
+            <a:pPr>
+              <a:spcAft>
+                <a:spcPts val="1200"/>
+              </a:spcAft>
+              <a:defRPr sz="2200">
+                <a:solidFill>
+                  <a:srgbClr val="1E293B"/>
+                </a:solidFill>
+              </a:defRPr>
+            </a:pPr>
+            <a:r>
+              <a:t>MySQL 8.0 или MariaDB 10.6+</a:t>
+            </a:r>
+          </a:p>
+          <a:p>
+            <a:pPr>
+              <a:spcAft>
+                <a:spcPts val="1200"/>
+              </a:spcAft>
+              <a:defRPr sz="2200">
+                <a:solidFill>
+                  <a:srgbClr val="1E293B"/>
+                </a:solidFill>
+              </a:defRPr>
+            </a:pPr>
+            <a:r>
+              <a:t>HTML5 и CSS</a:t>
+            </a:r>
+          </a:p>
+          <a:p>
+            <a:pPr>
+              <a:spcAft>
+                <a:spcPts val="1200"/>
+              </a:spcAft>
+              <a:defRPr sz="2200">
+                <a:solidFill>
+                  <a:srgbClr val="1E293B"/>
+                </a:solidFill>
+              </a:defRPr>
+            </a:pPr>
+            <a:r>
+              <a:t>Встроенный PHP-сервер для запуска</a:t>
+            </a:r>
+          </a:p>
+        </p:txBody>
+      </p:sp>
     </p:spTree>
   </p:cSld>
   <p:clrMapOvr>
@@ -3344,6 +3541,14 @@
 <file path=ppt/slides/slide4.xml><?xml version="1.0" encoding="utf-8"?>
 <p:sld xmlns:a="http://schemas.openxmlformats.org/drawingml/2006/main" xmlns:p="http://schemas.openxmlformats.org/presentationml/2006/main" xmlns:r="http://schemas.openxmlformats.org/officeDocument/2006/relationships">
   <p:cSld>
+    <p:bg>
+      <p:bgPr>
+        <a:solidFill>
+          <a:srgbClr val="F8FAFC"/>
+        </a:solidFill>
+        <a:effectLst/>
+      </p:bgPr>
+    </p:bg>
     <p:spTree>
       <p:nvGrpSpPr>
         <p:cNvPr id="1" name=""/>
@@ -3351,30 +3556,96 @@
         <p:nvPr/>
       </p:nvGrpSpPr>
       <p:grpSpPr/>
-      <p:pic>
-        <p:nvPicPr>
-          <p:cNvPr id="2" name="Picture 1" descr="slide_04_data_model.png"/>
-          <p:cNvPicPr>
-            <a:picLocks noChangeAspect="1"/>
-          </p:cNvPicPr>
+      <p:sp>
+        <p:nvSpPr>
+          <p:cNvPr id="2" name="Rectangle 1"/>
+          <p:cNvSpPr/>
           <p:nvPr/>
-        </p:nvPicPr>
-        <p:blipFill>
-          <a:blip r:embed="rId2"/>
-          <a:stretch>
-            <a:fillRect/>
-          </a:stretch>
-        </p:blipFill>
+        </p:nvSpPr>
         <p:spPr>
           <a:xfrm>
-            <a:off x="0" y="0"/>
-            <a:ext cx="12191695" cy="6858000"/>
+            <a:off x="457200" y="457200"/>
+            <a:ext cx="11247120" cy="731520"/>
           </a:xfrm>
           <a:prstGeom prst="rect">
             <a:avLst/>
           </a:prstGeom>
+          <a:solidFill>
+            <a:srgbClr val="0F172A"/>
+          </a:solidFill>
+          <a:ln>
+            <a:noFill/>
+          </a:ln>
         </p:spPr>
-      </p:pic>
+        <p:style>
+          <a:lnRef idx="1">
+            <a:schemeClr val="accent1"/>
+          </a:lnRef>
+          <a:fillRef idx="3">
+            <a:schemeClr val="accent1"/>
+          </a:fillRef>
+          <a:effectRef idx="2">
+            <a:schemeClr val="accent1"/>
+          </a:effectRef>
+          <a:fontRef idx="minor">
+            <a:schemeClr val="lt1"/>
+          </a:fontRef>
+        </p:style>
+        <p:txBody>
+          <a:bodyPr rtlCol="0" anchor="ctr"/>
+          <a:lstStyle/>
+          <a:p>
+            <a:pPr>
+              <a:defRPr sz="2600" b="1">
+                <a:solidFill>
+                  <a:srgbClr val="FFFFFF"/>
+                </a:solidFill>
+              </a:defRPr>
+            </a:pPr>
+            <a:r>
+              <a:t>Данные</a:t>
+            </a:r>
+          </a:p>
+        </p:txBody>
+      </p:sp>
+      <p:sp>
+        <p:nvSpPr>
+          <p:cNvPr id="3" name="TextBox 2"/>
+          <p:cNvSpPr txBox="1"/>
+          <p:nvPr/>
+        </p:nvSpPr>
+        <p:spPr>
+          <a:xfrm>
+            <a:off x="731520" y="1554480"/>
+            <a:ext cx="10789920" cy="4572000"/>
+          </a:xfrm>
+          <a:prstGeom prst="rect">
+            <a:avLst/>
+          </a:prstGeom>
+          <a:noFill/>
+        </p:spPr>
+        <p:txBody>
+          <a:bodyPr wrap="none">
+            <a:spAutoFit/>
+          </a:bodyPr>
+          <a:lstStyle/>
+          <a:p>
+            <a:pPr>
+              <a:spcAft>
+                <a:spcPts val="1200"/>
+              </a:spcAft>
+              <a:defRPr sz="2200">
+                <a:solidFill>
+                  <a:srgbClr val="1E293B"/>
+                </a:solidFill>
+              </a:defRPr>
+            </a:pPr>
+            <a:r>
+              <a:t>Демонстрационные таблицы: роли, пользователи, подразделения, стандарты, программы, планы, дисциплины, записки, согласование, компетенции и аудит.</a:t>
+            </a:r>
+          </a:p>
+        </p:txBody>
+      </p:sp>
     </p:spTree>
   </p:cSld>
   <p:clrMapOvr>
@@ -3386,6 +3657,14 @@
 <file path=ppt/slides/slide5.xml><?xml version="1.0" encoding="utf-8"?>
 <p:sld xmlns:a="http://schemas.openxmlformats.org/drawingml/2006/main" xmlns:p="http://schemas.openxmlformats.org/presentationml/2006/main" xmlns:r="http://schemas.openxmlformats.org/officeDocument/2006/relationships">
   <p:cSld>
+    <p:bg>
+      <p:bgPr>
+        <a:solidFill>
+          <a:srgbClr val="F8FAFC"/>
+        </a:solidFill>
+        <a:effectLst/>
+      </p:bgPr>
+    </p:bg>
     <p:spTree>
       <p:nvGrpSpPr>
         <p:cNvPr id="1" name=""/>
@@ -3393,30 +3672,186 @@
         <p:nvPr/>
       </p:nvGrpSpPr>
       <p:grpSpPr/>
-      <p:pic>
-        <p:nvPicPr>
-          <p:cNvPr id="2" name="Picture 1" descr="slide_05_portal_structure.png"/>
-          <p:cNvPicPr>
-            <a:picLocks noChangeAspect="1"/>
-          </p:cNvPicPr>
+      <p:sp>
+        <p:nvSpPr>
+          <p:cNvPr id="2" name="Rectangle 1"/>
+          <p:cNvSpPr/>
           <p:nvPr/>
-        </p:nvPicPr>
-        <p:blipFill>
-          <a:blip r:embed="rId2"/>
-          <a:stretch>
-            <a:fillRect/>
-          </a:stretch>
-        </p:blipFill>
+        </p:nvSpPr>
         <p:spPr>
           <a:xfrm>
-            <a:off x="0" y="0"/>
-            <a:ext cx="12191695" cy="6858000"/>
+            <a:off x="457200" y="457200"/>
+            <a:ext cx="11247120" cy="731520"/>
           </a:xfrm>
           <a:prstGeom prst="rect">
             <a:avLst/>
           </a:prstGeom>
+          <a:solidFill>
+            <a:srgbClr val="0F172A"/>
+          </a:solidFill>
+          <a:ln>
+            <a:noFill/>
+          </a:ln>
         </p:spPr>
-      </p:pic>
+        <p:style>
+          <a:lnRef idx="1">
+            <a:schemeClr val="accent1"/>
+          </a:lnRef>
+          <a:fillRef idx="3">
+            <a:schemeClr val="accent1"/>
+          </a:fillRef>
+          <a:effectRef idx="2">
+            <a:schemeClr val="accent1"/>
+          </a:effectRef>
+          <a:fontRef idx="minor">
+            <a:schemeClr val="lt1"/>
+          </a:fontRef>
+        </p:style>
+        <p:txBody>
+          <a:bodyPr rtlCol="0" anchor="ctr"/>
+          <a:lstStyle/>
+          <a:p>
+            <a:pPr>
+              <a:defRPr sz="2600" b="1">
+                <a:solidFill>
+                  <a:srgbClr val="FFFFFF"/>
+                </a:solidFill>
+              </a:defRPr>
+            </a:pPr>
+            <a:r>
+              <a:t>Разделы</a:t>
+            </a:r>
+          </a:p>
+        </p:txBody>
+      </p:sp>
+      <p:sp>
+        <p:nvSpPr>
+          <p:cNvPr id="3" name="TextBox 2"/>
+          <p:cNvSpPr txBox="1"/>
+          <p:nvPr/>
+        </p:nvSpPr>
+        <p:spPr>
+          <a:xfrm>
+            <a:off x="731520" y="1554480"/>
+            <a:ext cx="10789920" cy="4572000"/>
+          </a:xfrm>
+          <a:prstGeom prst="rect">
+            <a:avLst/>
+          </a:prstGeom>
+          <a:noFill/>
+        </p:spPr>
+        <p:txBody>
+          <a:bodyPr wrap="none">
+            <a:spAutoFit/>
+          </a:bodyPr>
+          <a:lstStyle/>
+          <a:p>
+            <a:pPr>
+              <a:spcAft>
+                <a:spcPts val="1200"/>
+              </a:spcAft>
+              <a:defRPr sz="2200">
+                <a:solidFill>
+                  <a:srgbClr val="1E293B"/>
+                </a:solidFill>
+              </a:defRPr>
+            </a:pPr>
+            <a:r>
+              <a:t>Сводная панель</a:t>
+            </a:r>
+          </a:p>
+          <a:p>
+            <a:pPr>
+              <a:spcAft>
+                <a:spcPts val="1200"/>
+              </a:spcAft>
+              <a:defRPr sz="2200">
+                <a:solidFill>
+                  <a:srgbClr val="1E293B"/>
+                </a:solidFill>
+              </a:defRPr>
+            </a:pPr>
+            <a:r>
+              <a:t>Учебные планы</a:t>
+            </a:r>
+          </a:p>
+          <a:p>
+            <a:pPr>
+              <a:spcAft>
+                <a:spcPts val="1200"/>
+              </a:spcAft>
+              <a:defRPr sz="2200">
+                <a:solidFill>
+                  <a:srgbClr val="1E293B"/>
+                </a:solidFill>
+              </a:defRPr>
+            </a:pPr>
+            <a:r>
+              <a:t>Проверка ФГОС</a:t>
+            </a:r>
+          </a:p>
+          <a:p>
+            <a:pPr>
+              <a:spcAft>
+                <a:spcPts val="1200"/>
+              </a:spcAft>
+              <a:defRPr sz="2200">
+                <a:solidFill>
+                  <a:srgbClr val="1E293B"/>
+                </a:solidFill>
+              </a:defRPr>
+            </a:pPr>
+            <a:r>
+              <a:t>Согласование</a:t>
+            </a:r>
+          </a:p>
+          <a:p>
+            <a:pPr>
+              <a:spcAft>
+                <a:spcPts val="1200"/>
+              </a:spcAft>
+              <a:defRPr sz="2200">
+                <a:solidFill>
+                  <a:srgbClr val="1E293B"/>
+                </a:solidFill>
+              </a:defRPr>
+            </a:pPr>
+            <a:r>
+              <a:t>Служебные записки</a:t>
+            </a:r>
+          </a:p>
+          <a:p>
+            <a:pPr>
+              <a:spcAft>
+                <a:spcPts val="1200"/>
+              </a:spcAft>
+              <a:defRPr sz="2200">
+                <a:solidFill>
+                  <a:srgbClr val="1E293B"/>
+                </a:solidFill>
+              </a:defRPr>
+            </a:pPr>
+            <a:r>
+              <a:t>Программы, стандарты, компетенции</a:t>
+            </a:r>
+          </a:p>
+          <a:p>
+            <a:pPr>
+              <a:spcAft>
+                <a:spcPts val="1200"/>
+              </a:spcAft>
+              <a:defRPr sz="2200">
+                <a:solidFill>
+                  <a:srgbClr val="1E293B"/>
+                </a:solidFill>
+              </a:defRPr>
+            </a:pPr>
+            <a:r>
+              <a:t>Подразделения, объявления, аудит</a:t>
+            </a:r>
+          </a:p>
+        </p:txBody>
+      </p:sp>
     </p:spTree>
   </p:cSld>
   <p:clrMapOvr>
@@ -3428,6 +3863,14 @@
 <file path=ppt/slides/slide6.xml><?xml version="1.0" encoding="utf-8"?>
 <p:sld xmlns:a="http://schemas.openxmlformats.org/drawingml/2006/main" xmlns:p="http://schemas.openxmlformats.org/presentationml/2006/main" xmlns:r="http://schemas.openxmlformats.org/officeDocument/2006/relationships">
   <p:cSld>
+    <p:bg>
+      <p:bgPr>
+        <a:solidFill>
+          <a:srgbClr val="F8FAFC"/>
+        </a:solidFill>
+        <a:effectLst/>
+      </p:bgPr>
+    </p:bg>
     <p:spTree>
       <p:nvGrpSpPr>
         <p:cNvPr id="1" name=""/>
@@ -3435,30 +3878,126 @@
         <p:nvPr/>
       </p:nvGrpSpPr>
       <p:grpSpPr/>
-      <p:pic>
-        <p:nvPicPr>
-          <p:cNvPr id="2" name="Picture 1" descr="slide_06_fgos_validation.png"/>
-          <p:cNvPicPr>
-            <a:picLocks noChangeAspect="1"/>
-          </p:cNvPicPr>
+      <p:sp>
+        <p:nvSpPr>
+          <p:cNvPr id="2" name="Rectangle 1"/>
+          <p:cNvSpPr/>
           <p:nvPr/>
-        </p:nvPicPr>
-        <p:blipFill>
-          <a:blip r:embed="rId2"/>
-          <a:stretch>
-            <a:fillRect/>
-          </a:stretch>
-        </p:blipFill>
+        </p:nvSpPr>
         <p:spPr>
           <a:xfrm>
-            <a:off x="0" y="0"/>
-            <a:ext cx="12191695" cy="6858000"/>
+            <a:off x="457200" y="457200"/>
+            <a:ext cx="11247120" cy="731520"/>
           </a:xfrm>
           <a:prstGeom prst="rect">
             <a:avLst/>
           </a:prstGeom>
+          <a:solidFill>
+            <a:srgbClr val="0F172A"/>
+          </a:solidFill>
+          <a:ln>
+            <a:noFill/>
+          </a:ln>
         </p:spPr>
-      </p:pic>
+        <p:style>
+          <a:lnRef idx="1">
+            <a:schemeClr val="accent1"/>
+          </a:lnRef>
+          <a:fillRef idx="3">
+            <a:schemeClr val="accent1"/>
+          </a:fillRef>
+          <a:effectRef idx="2">
+            <a:schemeClr val="accent1"/>
+          </a:effectRef>
+          <a:fontRef idx="minor">
+            <a:schemeClr val="lt1"/>
+          </a:fontRef>
+        </p:style>
+        <p:txBody>
+          <a:bodyPr rtlCol="0" anchor="ctr"/>
+          <a:lstStyle/>
+          <a:p>
+            <a:pPr>
+              <a:defRPr sz="2600" b="1">
+                <a:solidFill>
+                  <a:srgbClr val="FFFFFF"/>
+                </a:solidFill>
+              </a:defRPr>
+            </a:pPr>
+            <a:r>
+              <a:t>Запуск</a:t>
+            </a:r>
+          </a:p>
+        </p:txBody>
+      </p:sp>
+      <p:sp>
+        <p:nvSpPr>
+          <p:cNvPr id="3" name="TextBox 2"/>
+          <p:cNvSpPr txBox="1"/>
+          <p:nvPr/>
+        </p:nvSpPr>
+        <p:spPr>
+          <a:xfrm>
+            <a:off x="731520" y="1554480"/>
+            <a:ext cx="10789920" cy="4572000"/>
+          </a:xfrm>
+          <a:prstGeom prst="rect">
+            <a:avLst/>
+          </a:prstGeom>
+          <a:noFill/>
+        </p:spPr>
+        <p:txBody>
+          <a:bodyPr wrap="none">
+            <a:spAutoFit/>
+          </a:bodyPr>
+          <a:lstStyle/>
+          <a:p>
+            <a:pPr>
+              <a:spcAft>
+                <a:spcPts val="1200"/>
+              </a:spcAft>
+              <a:defRPr sz="2200">
+                <a:solidFill>
+                  <a:srgbClr val="1E293B"/>
+                </a:solidFill>
+              </a:defRPr>
+            </a:pPr>
+            <a:r>
+              <a:t>Создать базу MySQL/MariaDB.</a:t>
+            </a:r>
+          </a:p>
+          <a:p>
+            <a:pPr>
+              <a:spcAft>
+                <a:spcPts val="1200"/>
+              </a:spcAft>
+              <a:defRPr sz="2200">
+                <a:solidFill>
+                  <a:srgbClr val="1E293B"/>
+                </a:solidFill>
+              </a:defRPr>
+            </a:pPr>
+            <a:r>
+              <a:t>Выполнить database/schema.sql и database/seed.sql.</a:t>
+            </a:r>
+          </a:p>
+          <a:p>
+            <a:pPr>
+              <a:spcAft>
+                <a:spcPts val="1200"/>
+              </a:spcAft>
+              <a:defRPr sz="2200">
+                <a:solidFill>
+                  <a:srgbClr val="1E293B"/>
+                </a:solidFill>
+              </a:defRPr>
+            </a:pPr>
+            <a:r>
+              <a:t>Запустить: php -S 127.0.0.1:8000 -t portal</a:t>
+            </a:r>
+          </a:p>
+        </p:txBody>
+      </p:sp>
     </p:spTree>
   </p:cSld>
   <p:clrMapOvr>
@@ -3470,6 +4009,14 @@
 <file path=ppt/slides/slide7.xml><?xml version="1.0" encoding="utf-8"?>
 <p:sld xmlns:a="http://schemas.openxmlformats.org/drawingml/2006/main" xmlns:p="http://schemas.openxmlformats.org/presentationml/2006/main" xmlns:r="http://schemas.openxmlformats.org/officeDocument/2006/relationships">
   <p:cSld>
+    <p:bg>
+      <p:bgPr>
+        <a:solidFill>
+          <a:srgbClr val="F8FAFC"/>
+        </a:solidFill>
+        <a:effectLst/>
+      </p:bgPr>
+    </p:bg>
     <p:spTree>
       <p:nvGrpSpPr>
         <p:cNvPr id="1" name=""/>
@@ -3477,30 +4024,96 @@
         <p:nvPr/>
       </p:nvGrpSpPr>
       <p:grpSpPr/>
-      <p:pic>
-        <p:nvPicPr>
-          <p:cNvPr id="2" name="Picture 1" descr="slide_07_visual_diff.png"/>
-          <p:cNvPicPr>
-            <a:picLocks noChangeAspect="1"/>
-          </p:cNvPicPr>
+      <p:sp>
+        <p:nvSpPr>
+          <p:cNvPr id="2" name="Rectangle 1"/>
+          <p:cNvSpPr/>
           <p:nvPr/>
-        </p:nvPicPr>
-        <p:blipFill>
-          <a:blip r:embed="rId2"/>
-          <a:stretch>
-            <a:fillRect/>
-          </a:stretch>
-        </p:blipFill>
+        </p:nvSpPr>
         <p:spPr>
           <a:xfrm>
-            <a:off x="0" y="0"/>
-            <a:ext cx="12191695" cy="6858000"/>
+            <a:off x="457200" y="457200"/>
+            <a:ext cx="11247120" cy="731520"/>
           </a:xfrm>
           <a:prstGeom prst="rect">
             <a:avLst/>
           </a:prstGeom>
+          <a:solidFill>
+            <a:srgbClr val="0F172A"/>
+          </a:solidFill>
+          <a:ln>
+            <a:noFill/>
+          </a:ln>
         </p:spPr>
-      </p:pic>
+        <p:style>
+          <a:lnRef idx="1">
+            <a:schemeClr val="accent1"/>
+          </a:lnRef>
+          <a:fillRef idx="3">
+            <a:schemeClr val="accent1"/>
+          </a:fillRef>
+          <a:effectRef idx="2">
+            <a:schemeClr val="accent1"/>
+          </a:effectRef>
+          <a:fontRef idx="minor">
+            <a:schemeClr val="lt1"/>
+          </a:fontRef>
+        </p:style>
+        <p:txBody>
+          <a:bodyPr rtlCol="0" anchor="ctr"/>
+          <a:lstStyle/>
+          <a:p>
+            <a:pPr>
+              <a:defRPr sz="2600" b="1">
+                <a:solidFill>
+                  <a:srgbClr val="FFFFFF"/>
+                </a:solidFill>
+              </a:defRPr>
+            </a:pPr>
+            <a:r>
+              <a:t>Границы</a:t>
+            </a:r>
+          </a:p>
+        </p:txBody>
+      </p:sp>
+      <p:sp>
+        <p:nvSpPr>
+          <p:cNvPr id="3" name="TextBox 2"/>
+          <p:cNvSpPr txBox="1"/>
+          <p:nvPr/>
+        </p:nvSpPr>
+        <p:spPr>
+          <a:xfrm>
+            <a:off x="731520" y="1554480"/>
+            <a:ext cx="10789920" cy="4572000"/>
+          </a:xfrm>
+          <a:prstGeom prst="rect">
+            <a:avLst/>
+          </a:prstGeom>
+          <a:noFill/>
+        </p:spPr>
+        <p:txBody>
+          <a:bodyPr wrap="none">
+            <a:spAutoFit/>
+          </a:bodyPr>
+          <a:lstStyle/>
+          <a:p>
+            <a:pPr>
+              <a:spcAft>
+                <a:spcPts val="1200"/>
+              </a:spcAft>
+              <a:defRPr sz="2200">
+                <a:solidFill>
+                  <a:srgbClr val="1E293B"/>
+                </a:solidFill>
+              </a:defRPr>
+            </a:pPr>
+            <a:r>
+              <a:t>Не реализованы: авторизация, редактирование через формы, полноценный RBAC, автоматический движок ФГОС, квалифицированная ЭЦП, экспорт и внешние интеграции.</a:t>
+            </a:r>
+          </a:p>
+        </p:txBody>
+      </p:sp>
     </p:spTree>
   </p:cSld>
   <p:clrMapOvr>
@@ -3512,6 +4125,14 @@
 <file path=ppt/slides/slide8.xml><?xml version="1.0" encoding="utf-8"?>
 <p:sld xmlns:a="http://schemas.openxmlformats.org/drawingml/2006/main" xmlns:p="http://schemas.openxmlformats.org/presentationml/2006/main" xmlns:r="http://schemas.openxmlformats.org/officeDocument/2006/relationships">
   <p:cSld>
+    <p:bg>
+      <p:bgPr>
+        <a:solidFill>
+          <a:srgbClr val="F8FAFC"/>
+        </a:solidFill>
+        <a:effectLst/>
+      </p:bgPr>
+    </p:bg>
     <p:spTree>
       <p:nvGrpSpPr>
         <p:cNvPr id="1" name=""/>
@@ -3519,72 +4140,96 @@
         <p:nvPr/>
       </p:nvGrpSpPr>
       <p:grpSpPr/>
-      <p:pic>
-        <p:nvPicPr>
-          <p:cNvPr id="2" name="Picture 1" descr="slide_08_crypto_signature.png"/>
-          <p:cNvPicPr>
-            <a:picLocks noChangeAspect="1"/>
-          </p:cNvPicPr>
+      <p:sp>
+        <p:nvSpPr>
+          <p:cNvPr id="2" name="Rectangle 1"/>
+          <p:cNvSpPr/>
           <p:nvPr/>
-        </p:nvPicPr>
-        <p:blipFill>
-          <a:blip r:embed="rId2"/>
-          <a:stretch>
-            <a:fillRect/>
-          </a:stretch>
-        </p:blipFill>
+        </p:nvSpPr>
         <p:spPr>
           <a:xfrm>
-            <a:off x="0" y="0"/>
-            <a:ext cx="12191695" cy="6858000"/>
+            <a:off x="457200" y="457200"/>
+            <a:ext cx="11247120" cy="731520"/>
           </a:xfrm>
           <a:prstGeom prst="rect">
             <a:avLst/>
           </a:prstGeom>
+          <a:solidFill>
+            <a:srgbClr val="0F172A"/>
+          </a:solidFill>
+          <a:ln>
+            <a:noFill/>
+          </a:ln>
         </p:spPr>
-      </p:pic>
-    </p:spTree>
-  </p:cSld>
-  <p:clrMapOvr>
-    <a:masterClrMapping/>
-  </p:clrMapOvr>
-</p:sld>
-</file>
-
-<file path=ppt/slides/slide9.xml><?xml version="1.0" encoding="utf-8"?>
-<p:sld xmlns:a="http://schemas.openxmlformats.org/drawingml/2006/main" xmlns:p="http://schemas.openxmlformats.org/presentationml/2006/main" xmlns:r="http://schemas.openxmlformats.org/officeDocument/2006/relationships">
-  <p:cSld>
-    <p:spTree>
-      <p:nvGrpSpPr>
-        <p:cNvPr id="1" name=""/>
-        <p:cNvGrpSpPr/>
-        <p:nvPr/>
-      </p:nvGrpSpPr>
-      <p:grpSpPr/>
-      <p:pic>
-        <p:nvPicPr>
-          <p:cNvPr id="2" name="Picture 1" descr="slide_09_analytics_export.png"/>
-          <p:cNvPicPr>
-            <a:picLocks noChangeAspect="1"/>
-          </p:cNvPicPr>
+        <p:style>
+          <a:lnRef idx="1">
+            <a:schemeClr val="accent1"/>
+          </a:lnRef>
+          <a:fillRef idx="3">
+            <a:schemeClr val="accent1"/>
+          </a:fillRef>
+          <a:effectRef idx="2">
+            <a:schemeClr val="accent1"/>
+          </a:effectRef>
+          <a:fontRef idx="minor">
+            <a:schemeClr val="lt1"/>
+          </a:fontRef>
+        </p:style>
+        <p:txBody>
+          <a:bodyPr rtlCol="0" anchor="ctr"/>
+          <a:lstStyle/>
+          <a:p>
+            <a:pPr>
+              <a:defRPr sz="2600" b="1">
+                <a:solidFill>
+                  <a:srgbClr val="FFFFFF"/>
+                </a:solidFill>
+              </a:defRPr>
+            </a:pPr>
+            <a:r>
+              <a:t>Итог</a:t>
+            </a:r>
+          </a:p>
+        </p:txBody>
+      </p:sp>
+      <p:sp>
+        <p:nvSpPr>
+          <p:cNvPr id="3" name="TextBox 2"/>
+          <p:cNvSpPr txBox="1"/>
           <p:nvPr/>
-        </p:nvPicPr>
-        <p:blipFill>
-          <a:blip r:embed="rId2"/>
-          <a:stretch>
-            <a:fillRect/>
-          </a:stretch>
-        </p:blipFill>
+        </p:nvSpPr>
         <p:spPr>
           <a:xfrm>
-            <a:off x="0" y="0"/>
-            <a:ext cx="12191695" cy="6858000"/>
+            <a:off x="731520" y="1554480"/>
+            <a:ext cx="10789920" cy="4572000"/>
           </a:xfrm>
           <a:prstGeom prst="rect">
             <a:avLst/>
           </a:prstGeom>
+          <a:noFill/>
         </p:spPr>
-      </p:pic>
+        <p:txBody>
+          <a:bodyPr wrap="none">
+            <a:spAutoFit/>
+          </a:bodyPr>
+          <a:lstStyle/>
+          <a:p>
+            <a:pPr>
+              <a:spcAft>
+                <a:spcPts val="1200"/>
+              </a:spcAft>
+              <a:defRPr sz="2200">
+                <a:solidFill>
+                  <a:srgbClr val="1E293B"/>
+                </a:solidFill>
+              </a:defRPr>
+            </a:pPr>
+            <a:r>
+              <a:t>Подготовлен учебный PHP-портал с MySQL/MariaDB и демонстрационными данными. Документы описывают фактический результат.</a:t>
+            </a:r>
+          </a:p>
+        </p:txBody>
+      </p:sp>
     </p:spTree>
   </p:cSld>
   <p:clrMapOvr>

</xml_diff>

<commit_message>
Fix presentation layout: text overflow, mid-word cuts, off-slide card; rebuild slides/PPTX/PDF
Co-authored-by: arena-agent <297053741+arena-agent@users.noreply.github.com>
</commit_message>
<xml_diff>
--- a/reports/lab7/LR7_Presentation_Variant15.pptx
+++ b/reports/lab7/LR7_Presentation_Variant15.pptx
@@ -18,7 +18,7 @@
     <p:sldId id="266" r:id="rId17"/>
     <p:sldId id="267" r:id="rId18"/>
   </p:sldIdLst>
-  <p:sldSz cx="12191695" cy="6858000" type="screen4x3"/>
+  <p:sldSz cx="12192000" cy="6858000" type="screen4x3"/>
   <p:notesSz cx="6858000" cy="9144000"/>
   <p:defaultTextStyle>
     <a:defPPr>
@@ -3116,7 +3116,7 @@
         <p:spPr>
           <a:xfrm>
             <a:off x="0" y="0"/>
-            <a:ext cx="12191695" cy="6858000"/>
+            <a:ext cx="12192000" cy="6858000"/>
           </a:xfrm>
           <a:prstGeom prst="rect">
             <a:avLst/>
@@ -3158,7 +3158,7 @@
         <p:spPr>
           <a:xfrm>
             <a:off x="0" y="0"/>
-            <a:ext cx="12191695" cy="6858000"/>
+            <a:ext cx="12192000" cy="6858000"/>
           </a:xfrm>
           <a:prstGeom prst="rect">
             <a:avLst/>
@@ -3200,7 +3200,7 @@
         <p:spPr>
           <a:xfrm>
             <a:off x="0" y="0"/>
-            <a:ext cx="12191695" cy="6858000"/>
+            <a:ext cx="12192000" cy="6858000"/>
           </a:xfrm>
           <a:prstGeom prst="rect">
             <a:avLst/>
@@ -3242,7 +3242,7 @@
         <p:spPr>
           <a:xfrm>
             <a:off x="0" y="0"/>
-            <a:ext cx="12191695" cy="6858000"/>
+            <a:ext cx="12192000" cy="6858000"/>
           </a:xfrm>
           <a:prstGeom prst="rect">
             <a:avLst/>
@@ -3284,7 +3284,7 @@
         <p:spPr>
           <a:xfrm>
             <a:off x="0" y="0"/>
-            <a:ext cx="12191695" cy="6858000"/>
+            <a:ext cx="12192000" cy="6858000"/>
           </a:xfrm>
           <a:prstGeom prst="rect">
             <a:avLst/>
@@ -3326,7 +3326,7 @@
         <p:spPr>
           <a:xfrm>
             <a:off x="0" y="0"/>
-            <a:ext cx="12191695" cy="6858000"/>
+            <a:ext cx="12192000" cy="6858000"/>
           </a:xfrm>
           <a:prstGeom prst="rect">
             <a:avLst/>
@@ -3368,7 +3368,7 @@
         <p:spPr>
           <a:xfrm>
             <a:off x="0" y="0"/>
-            <a:ext cx="12191695" cy="6858000"/>
+            <a:ext cx="12192000" cy="6858000"/>
           </a:xfrm>
           <a:prstGeom prst="rect">
             <a:avLst/>
@@ -3410,7 +3410,7 @@
         <p:spPr>
           <a:xfrm>
             <a:off x="0" y="0"/>
-            <a:ext cx="12191695" cy="6858000"/>
+            <a:ext cx="12192000" cy="6858000"/>
           </a:xfrm>
           <a:prstGeom prst="rect">
             <a:avLst/>
@@ -3452,7 +3452,7 @@
         <p:spPr>
           <a:xfrm>
             <a:off x="0" y="0"/>
-            <a:ext cx="12191695" cy="6858000"/>
+            <a:ext cx="12192000" cy="6858000"/>
           </a:xfrm>
           <a:prstGeom prst="rect">
             <a:avLst/>
@@ -3494,7 +3494,7 @@
         <p:spPr>
           <a:xfrm>
             <a:off x="0" y="0"/>
-            <a:ext cx="12191695" cy="6858000"/>
+            <a:ext cx="12192000" cy="6858000"/>
           </a:xfrm>
           <a:prstGeom prst="rect">
             <a:avLst/>
@@ -3536,7 +3536,7 @@
         <p:spPr>
           <a:xfrm>
             <a:off x="0" y="0"/>
-            <a:ext cx="12191695" cy="6858000"/>
+            <a:ext cx="12192000" cy="6858000"/>
           </a:xfrm>
           <a:prstGeom prst="rect">
             <a:avLst/>
@@ -3578,7 +3578,7 @@
         <p:spPr>
           <a:xfrm>
             <a:off x="0" y="0"/>
-            <a:ext cx="12191695" cy="6858000"/>
+            <a:ext cx="12192000" cy="6858000"/>
           </a:xfrm>
           <a:prstGeom prst="rect">
             <a:avLst/>

</xml_diff>